<commit_message>
feat: add dynamic K-means, multi-metric FP-growth, ML visualizers, and Star Schema Warehouse view
- Add interactive K-value selector (K=2..6) with dual-axis Elbow/Silhouette accuracy curve
- Add FP-Growth 3-slider filter studio (min_support, min_confidence, min_lift) with rule bubble scatter chart
- Add 4-chart ML inference dashboard (probability distribution, recurrence gauge, SLA benchmark, SHAP attribution) with glassmorphism loading overlay
- Build dedicated Star Schema Warehouse Architecture view (/warehouse) with interactive ER model & attribute inspector
- Declutter Overview UI with interactive Ward Telemetry Bar Chart, SLA Compliance Doughnut, and Channel Mix Chart
- Update README.md and automated test suite (30/30 tests passing)
</commit_message>
<xml_diff>
--- a/Presentation/BMC Grievances Phase 2 Data Mining.pptx
+++ b/Presentation/BMC Grievances Phase 2 Data Mining.pptx
@@ -4,6 +4,9 @@
   <p:sldMasterIdLst>
     <p:sldMasterId id="2147483648" r:id="rId1"/>
   </p:sldMasterIdLst>
+  <p:notesMasterIdLst>
+    <p:notesMasterId r:id="rId13"/>
+  </p:notesMasterIdLst>
   <p:sldIdLst>
     <p:sldId id="256" r:id="rId2"/>
     <p:sldId id="257" r:id="rId3"/>
@@ -17,9 +20,6 @@
     <p:sldId id="265" r:id="rId11"/>
     <p:sldId id="266" r:id="rId12"/>
   </p:sldIdLst>
-  <p:notesMasterIdLst>
-    <p:notesMasterId r:id="rId13"/>
-  </p:notesMasterIdLst>
   <p:sldSz cx="12192000" cy="6858000"/>
   <p:notesSz cx="6858000" cy="12192000"/>
   <p:defaultTextStyle>
@@ -114,6 +114,11 @@
       </a:defRPr>
     </a:lvl9pPr>
   </p:defaultTextStyle>
+  <p:extLst>
+    <p:ext uri="{EFAFB233-063F-42B5-8137-9DF3F51BA10A}">
+      <p15:sldGuideLst xmlns:p15="http://schemas.microsoft.com/office/powerpoint/2012/main"/>
+    </p:ext>
+  </p:extLst>
 </p:presentation>
 </file>
 
@@ -139,234 +144,10 @@
           <a:chExt cx="0" cy="0"/>
         </a:xfrm>
       </p:grpSpPr>
-      <p:sp>
-        <p:nvSpPr>
-          <p:cNvPr id="2" name="Header Placeholder 1"/>
-          <p:cNvSpPr>
-            <a:spLocks noGrp="1"/>
-          </p:cNvSpPr>
-          <p:nvPr>
-            <p:ph type="hdr" sz="quarter"/>
-          </p:nvPr>
-        </p:nvSpPr>
-        <p:spPr>
-          <a:xfrm>
-            <a:off x="0" y="0"/>
-            <a:ext cx="2971800" cy="458788"/>
-          </a:xfrm>
-          <a:prstGeom prst="rect">
-            <a:avLst/>
-          </a:prstGeom>
-        </p:spPr>
-        <p:txBody>
-          <a:bodyPr vert="horz" lIns="91440" tIns="45720" rIns="91440" bIns="45720" rtlCol="0"/>
-          <a:lstStyle>
-            <a:lvl1pPr algn="l">
-              <a:defRPr sz="1200"/>
-            </a:lvl1pPr>
-          </a:lstStyle>
-          <a:p>
-            <a:endParaRPr lang="en-US"/>
-          </a:p>
-        </p:txBody>
-      </p:sp>
-      <p:sp>
-        <p:nvSpPr>
-          <p:cNvPr id="3" name="Date Placeholder 2"/>
-          <p:cNvSpPr>
-            <a:spLocks noGrp="1"/>
-          </p:cNvSpPr>
-          <p:nvPr>
-            <p:ph type="dt" idx="1"/>
-          </p:nvPr>
-        </p:nvSpPr>
-        <p:spPr>
-          <a:xfrm>
-            <a:off x="3884613" y="0"/>
-            <a:ext cx="2971800" cy="458788"/>
-          </a:xfrm>
-          <a:prstGeom prst="rect">
-            <a:avLst/>
-          </a:prstGeom>
-        </p:spPr>
-        <p:txBody>
-          <a:bodyPr vert="horz" lIns="91440" tIns="45720" rIns="91440" bIns="45720" rtlCol="0"/>
-          <a:lstStyle>
-            <a:lvl1pPr algn="r">
-              <a:defRPr sz="1200"/>
-            </a:lvl1pPr>
-          </a:lstStyle>
-          <a:p>
-            <a:fld id="{5282F153-3F37-0F45-9E97-73ACFA13230C}" type="datetimeFigureOut">
-              <a:rPr lang="en-US"/>
-              <a:t>7/23/19</a:t>
-            </a:fld>
-            <a:endParaRPr lang="en-US"/>
-          </a:p>
-        </p:txBody>
-      </p:sp>
-      <p:sp>
-        <p:nvSpPr>
-          <p:cNvPr id="4" name="Slide Image Placeholder 3"/>
-          <p:cNvSpPr>
-            <a:spLocks noGrp="1" noRot="1" noChangeAspect="1"/>
-          </p:cNvSpPr>
-          <p:nvPr>
-            <p:ph type="sldImg" idx="2"/>
-          </p:nvPr>
-        </p:nvSpPr>
-        <p:spPr>
-          <a:xfrm>
-            <a:off x="685800" y="1143000"/>
-            <a:ext cx="5486400" cy="3086100"/>
-          </a:xfrm>
-          <a:prstGeom prst="rect">
-            <a:avLst/>
-          </a:prstGeom>
-          <a:noFill/>
-          <a:ln w="12700">
-            <a:solidFill>
-              <a:prstClr val="black"/>
-            </a:solidFill>
-          </a:ln>
-        </p:spPr>
-        <p:txBody>
-          <a:bodyPr vert="horz" lIns="91440" tIns="45720" rIns="91440" bIns="45720" rtlCol="0" anchor="ctr"/>
-          <a:lstStyle/>
-          <a:p>
-            <a:endParaRPr lang="en-US"/>
-          </a:p>
-        </p:txBody>
-      </p:sp>
-      <p:sp>
-        <p:nvSpPr>
-          <p:cNvPr id="5" name="Notes Placeholder 4"/>
-          <p:cNvSpPr>
-            <a:spLocks noGrp="1"/>
-          </p:cNvSpPr>
-          <p:nvPr>
-            <p:ph type="body" sz="quarter" idx="3"/>
-          </p:nvPr>
-        </p:nvSpPr>
-        <p:spPr>
-          <a:xfrm>
-            <a:off x="685800" y="4400550"/>
-            <a:ext cx="5486400" cy="3600450"/>
-          </a:xfrm>
-          <a:prstGeom prst="rect">
-            <a:avLst/>
-          </a:prstGeom>
-        </p:spPr>
-        <p:txBody>
-          <a:bodyPr vert="horz" lIns="91440" tIns="45720" rIns="91440" bIns="45720" rtlCol="0"/>
-          <a:lstStyle/>
-          <a:p>
-            <a:pPr lvl="0"/>
-            <a:r>
-              <a:rPr lang="en-US"/>
-              <a:t>Click to edit Master text styles</a:t>
-            </a:r>
-          </a:p>
-          <a:p>
-            <a:pPr lvl="1"/>
-            <a:r>
-              <a:rPr lang="en-US"/>
-              <a:t>Second level</a:t>
-            </a:r>
-          </a:p>
-          <a:p>
-            <a:pPr lvl="2"/>
-            <a:r>
-              <a:rPr lang="en-US"/>
-              <a:t>Third level</a:t>
-            </a:r>
-          </a:p>
-          <a:p>
-            <a:pPr lvl="3"/>
-            <a:r>
-              <a:rPr lang="en-US"/>
-              <a:t>Fourth level</a:t>
-            </a:r>
-          </a:p>
-          <a:p>
-            <a:pPr lvl="4"/>
-            <a:r>
-              <a:rPr lang="en-US"/>
-              <a:t>Fifth level</a:t>
-            </a:r>
-          </a:p>
-        </p:txBody>
-      </p:sp>
-      <p:sp>
-        <p:nvSpPr>
-          <p:cNvPr id="6" name="Footer Placeholder 5"/>
-          <p:cNvSpPr>
-            <a:spLocks noGrp="1"/>
-          </p:cNvSpPr>
-          <p:nvPr>
-            <p:ph type="ftr" sz="quarter" idx="4"/>
-          </p:nvPr>
-        </p:nvSpPr>
-        <p:spPr>
-          <a:xfrm>
-            <a:off x="0" y="8685213"/>
-            <a:ext cx="2971800" cy="458787"/>
-          </a:xfrm>
-          <a:prstGeom prst="rect">
-            <a:avLst/>
-          </a:prstGeom>
-        </p:spPr>
-        <p:txBody>
-          <a:bodyPr vert="horz" lIns="91440" tIns="45720" rIns="91440" bIns="45720" rtlCol="0" anchor="b"/>
-          <a:lstStyle>
-            <a:lvl1pPr algn="l">
-              <a:defRPr sz="1200"/>
-            </a:lvl1pPr>
-          </a:lstStyle>
-          <a:p>
-            <a:endParaRPr lang="en-US"/>
-          </a:p>
-        </p:txBody>
-      </p:sp>
-      <p:sp>
-        <p:nvSpPr>
-          <p:cNvPr id="7" name="Slide Number Placeholder 6"/>
-          <p:cNvSpPr>
-            <a:spLocks noGrp="1"/>
-          </p:cNvSpPr>
-          <p:nvPr>
-            <p:ph type="sldNum" sz="quarter" idx="5"/>
-          </p:nvPr>
-        </p:nvSpPr>
-        <p:spPr>
-          <a:xfrm>
-            <a:off x="3884613" y="8685213"/>
-            <a:ext cx="2971800" cy="458787"/>
-          </a:xfrm>
-          <a:prstGeom prst="rect">
-            <a:avLst/>
-          </a:prstGeom>
-        </p:spPr>
-        <p:txBody>
-          <a:bodyPr vert="horz" lIns="91440" tIns="45720" rIns="91440" bIns="45720" rtlCol="0" anchor="b"/>
-          <a:lstStyle>
-            <a:lvl1pPr algn="r">
-              <a:defRPr sz="1200"/>
-            </a:lvl1pPr>
-          </a:lstStyle>
-          <a:p>
-            <a:fld id="{CE5E9CC1-C706-0F49-92D6-E571CC5EEA8F}" type="slidenum">
-              <a:rPr lang="en-US"/>
-              <a:t>‹#›</a:t>
-            </a:fld>
-            <a:endParaRPr lang="en-US"/>
-          </a:p>
-        </p:txBody>
-      </p:sp>
     </p:spTree>
     <p:extLst>
       <p:ext uri="{BB962C8B-B14F-4D97-AF65-F5344CB8AC3E}">
-        <p14:creationId xmlns:p14="http://schemas.microsoft.com/office/powerpoint/2010/main" val="1024086991"/>
+        <p14:creationId xmlns:p14="http://schemas.microsoft.com/office/powerpoint/2010/main" val="2601756299"/>
       </p:ext>
     </p:extLst>
   </p:cSld>
@@ -514,7 +295,6 @@
               <a:rPr lang="en-US" dirty="0"/>
               <a:t>Dataset: 960,000 Mumbai BMC grievance records in a PostgreSQL star-schema warehouse. Four mining tasks follow, then a synthesis.</a:t>
             </a:r>
-            <a:endParaRPr lang="en-US" dirty="0"/>
           </a:p>
         </p:txBody>
       </p:sp>
@@ -602,7 +382,6 @@
               <a:rPr lang="en-US" dirty="0"/>
               <a:t>The re-test without prior_complaints_count, log_prior_complaints and is_heavy_user checks that the model is not simply reading the label.</a:t>
             </a:r>
-            <a:endParaRPr lang="en-US" dirty="0"/>
           </a:p>
         </p:txBody>
       </p:sp>
@@ -686,10 +465,6 @@
           <a:bodyPr/>
           <a:lstStyle/>
           <a:p>
-            <a:r>
-              <a:rPr lang="en-US" dirty="0"/>
-              <a:t/>
-            </a:r>
             <a:endParaRPr lang="en-US" dirty="0"/>
           </a:p>
         </p:txBody>
@@ -778,7 +553,6 @@
               <a:rPr lang="en-US" dirty="0"/>
               <a:t>Baseline used only demographics (ward, zone, channel, severity), which carry almost no information about complaint type. The accuracy jump comes from operational, financial and asset-stress features. Caveat to be ready for: cost and resolution days are known after a case is handled, so this is a post-hoc categorization model, not strictly an intake-time one.</a:t>
             </a:r>
-            <a:endParaRPr lang="en-US" dirty="0"/>
           </a:p>
         </p:txBody>
       </p:sp>
@@ -862,10 +636,6 @@
           <a:bodyPr/>
           <a:lstStyle/>
           <a:p>
-            <a:r>
-              <a:rPr lang="en-US" dirty="0"/>
-              <a:t/>
-            </a:r>
             <a:endParaRPr lang="en-US" dirty="0"/>
           </a:p>
         </p:txBody>
@@ -950,10 +720,6 @@
           <a:bodyPr/>
           <a:lstStyle/>
           <a:p>
-            <a:r>
-              <a:rPr lang="en-US" dirty="0"/>
-              <a:t/>
-            </a:r>
             <a:endParaRPr lang="en-US" dirty="0"/>
           </a:p>
         </p:txBody>
@@ -1042,7 +808,6 @@
               <a:rPr lang="en-US" dirty="0"/>
               <a:t>Each point is a complaint type aggregated from the warehouse: avg resolution days, avg cost, repeat rate, satisfaction rate, slum share, monsoon share, high-severity share.</a:t>
             </a:r>
-            <a:endParaRPr lang="en-US" dirty="0"/>
           </a:p>
         </p:txBody>
       </p:sp>
@@ -1126,10 +891,6 @@
           <a:bodyPr/>
           <a:lstStyle/>
           <a:p>
-            <a:r>
-              <a:rPr lang="en-US" dirty="0"/>
-              <a:t/>
-            </a:r>
             <a:endParaRPr lang="en-US" dirty="0"/>
           </a:p>
         </p:txBody>
@@ -1214,10 +975,6 @@
           <a:bodyPr/>
           <a:lstStyle/>
           <a:p>
-            <a:r>
-              <a:rPr lang="en-US" dirty="0"/>
-              <a:t/>
-            </a:r>
             <a:endParaRPr lang="en-US" dirty="0"/>
           </a:p>
         </p:txBody>
@@ -1302,10 +1059,6 @@
           <a:bodyPr/>
           <a:lstStyle/>
           <a:p>
-            <a:r>
-              <a:rPr lang="en-US" dirty="0"/>
-              <a:t/>
-            </a:r>
             <a:endParaRPr lang="en-US" dirty="0"/>
           </a:p>
         </p:txBody>
@@ -1394,7 +1147,6 @@
               <a:rPr lang="en-US" dirty="0"/>
               <a:t>Be ready for this question: repeat_complainant is registered when prior_complaints_count is above 0, so that feature nearly defines the label. That explains the 100%. A stricter evaluation drops prior_complaints_count, log_prior_complaints and is_heavy_user and relies on asset and location features only.</a:t>
             </a:r>
-            <a:endParaRPr lang="en-US" dirty="0"/>
           </a:p>
         </p:txBody>
       </p:sp>
@@ -1472,6 +1224,7 @@
         <a:solidFill>
           <a:srgbClr val="F5F3EE"/>
         </a:solidFill>
+        <a:effectLst/>
       </p:bgPr>
     </p:bg>
     <p:spTree>
@@ -1491,7 +1244,9 @@
       <p:sp>
         <p:nvSpPr>
           <p:cNvPr id="2" name="Title Placeholder 1"/>
-          <p:cNvSpPr/>
+          <p:cNvSpPr>
+            <a:spLocks noGrp="1"/>
+          </p:cNvSpPr>
           <p:nvPr>
             <p:ph type="title"/>
           </p:nvPr>
@@ -1510,7 +1265,7 @@
         <p:txBody>
           <a:bodyPr wrap="square" lIns="0" tIns="0" rIns="0" bIns="0" rtlCol="0" anchor="t"/>
           <a:lstStyle>
-            <a:lvl1pPr algn="l" indent="0" marL="0">
+            <a:lvl1pPr marL="0" indent="0" algn="l">
               <a:lnSpc>
                 <a:spcPct val="115000"/>
               </a:lnSpc>
@@ -1526,7 +1281,7 @@
             </a:lvl1pPr>
           </a:lstStyle>
           <a:p>
-            <a:pPr algn="l" indent="0" marL="0">
+            <a:pPr marL="0" indent="0" algn="l">
               <a:lnSpc>
                 <a:spcPct val="115000"/>
               </a:lnSpc>
@@ -1539,9 +1294,11 @@
       <p:sp>
         <p:nvSpPr>
           <p:cNvPr id="3" name="Text Placeholder 2"/>
-          <p:cNvSpPr/>
+          <p:cNvSpPr>
+            <a:spLocks noGrp="1"/>
+          </p:cNvSpPr>
           <p:nvPr>
-            <p:ph idx="101" type="body"/>
+            <p:ph type="body" idx="101"/>
           </p:nvPr>
         </p:nvSpPr>
         <p:spPr>
@@ -1558,7 +1315,7 @@
         <p:txBody>
           <a:bodyPr wrap="square" lIns="0" tIns="0" rIns="0" bIns="0" rtlCol="0" anchor="t"/>
           <a:lstStyle>
-            <a:lvl1pPr algn="l" indent="0" marL="0">
+            <a:lvl1pPr marL="0" indent="0" algn="l">
               <a:lnSpc>
                 <a:spcPct val="140000"/>
               </a:lnSpc>
@@ -1574,7 +1331,7 @@
             </a:lvl1pPr>
           </a:lstStyle>
           <a:p>
-            <a:pPr algn="l" indent="0" marL="0">
+            <a:pPr marL="0" indent="0" algn="l">
               <a:lnSpc>
                 <a:spcPct val="140000"/>
               </a:lnSpc>
@@ -1600,6 +1357,7 @@
         <a:solidFill>
           <a:srgbClr val="F5F3EE"/>
         </a:solidFill>
+        <a:effectLst/>
       </p:bgPr>
     </p:bg>
     <p:spTree>
@@ -1619,7 +1377,9 @@
       <p:sp>
         <p:nvSpPr>
           <p:cNvPr id="2" name="Title Placeholder 1"/>
-          <p:cNvSpPr/>
+          <p:cNvSpPr>
+            <a:spLocks noGrp="1"/>
+          </p:cNvSpPr>
           <p:nvPr>
             <p:ph type="title"/>
           </p:nvPr>
@@ -1638,7 +1398,7 @@
         <p:txBody>
           <a:bodyPr wrap="square" lIns="0" tIns="0" rIns="0" bIns="0" rtlCol="0" anchor="t"/>
           <a:lstStyle>
-            <a:lvl1pPr algn="l" indent="0" marL="0">
+            <a:lvl1pPr marL="0" indent="0" algn="l">
               <a:lnSpc>
                 <a:spcPct val="115000"/>
               </a:lnSpc>
@@ -1654,7 +1414,7 @@
             </a:lvl1pPr>
           </a:lstStyle>
           <a:p>
-            <a:pPr algn="l" indent="0" marL="0">
+            <a:pPr marL="0" indent="0" algn="l">
               <a:lnSpc>
                 <a:spcPct val="115000"/>
               </a:lnSpc>
@@ -1667,9 +1427,11 @@
       <p:sp>
         <p:nvSpPr>
           <p:cNvPr id="3" name="Text Placeholder 2"/>
-          <p:cNvSpPr/>
+          <p:cNvSpPr>
+            <a:spLocks noGrp="1"/>
+          </p:cNvSpPr>
           <p:nvPr>
-            <p:ph idx="101" type="body"/>
+            <p:ph type="body" idx="101"/>
           </p:nvPr>
         </p:nvSpPr>
         <p:spPr>
@@ -1686,7 +1448,7 @@
         <p:txBody>
           <a:bodyPr wrap="square" lIns="0" tIns="0" rIns="0" bIns="0" rtlCol="0" anchor="t"/>
           <a:lstStyle>
-            <a:lvl1pPr algn="l" indent="0" marL="0">
+            <a:lvl1pPr marL="0" indent="0" algn="l">
               <a:lnSpc>
                 <a:spcPct val="140000"/>
               </a:lnSpc>
@@ -1702,7 +1464,7 @@
             </a:lvl1pPr>
           </a:lstStyle>
           <a:p>
-            <a:pPr algn="l" indent="0" marL="0">
+            <a:pPr marL="0" indent="0" algn="l">
               <a:lnSpc>
                 <a:spcPct val="140000"/>
               </a:lnSpc>
@@ -1981,6 +1743,7 @@
         <a:solidFill>
           <a:srgbClr val="14213D"/>
         </a:solidFill>
+        <a:effectLst/>
       </p:bgPr>
     </p:bg>
     <p:spTree>
@@ -2020,7 +1783,7 @@
           </a:bodyPr>
           <a:lstStyle/>
           <a:p>
-            <a:pPr algn="l" indent="0" marL="0">
+            <a:pPr marL="0" indent="0" algn="l">
               <a:lnSpc>
                 <a:spcPts val="2240"/>
               </a:lnSpc>
@@ -2044,7 +1807,9 @@
       <p:sp>
         <p:nvSpPr>
           <p:cNvPr id="3" name="Text 1"/>
-          <p:cNvSpPr/>
+          <p:cNvSpPr>
+            <a:spLocks noGrp="1"/>
+          </p:cNvSpPr>
           <p:nvPr>
             <p:ph type="title"/>
           </p:nvPr>
@@ -2066,7 +1831,7 @@
           </a:bodyPr>
           <a:lstStyle/>
           <a:p>
-            <a:pPr algn="l" indent="0" marL="0">
+            <a:pPr marL="0" indent="0" algn="l">
               <a:lnSpc>
                 <a:spcPts val="5460"/>
               </a:lnSpc>
@@ -2110,7 +1875,7 @@
           </a:bodyPr>
           <a:lstStyle/>
           <a:p>
-            <a:pPr algn="l" indent="0" marL="0">
+            <a:pPr marL="0" indent="0" algn="l">
               <a:lnSpc>
                 <a:spcPts val="2800"/>
               </a:lnSpc>
@@ -2147,6 +1912,7 @@
         <a:solidFill>
           <a:srgbClr val="F5F3EE"/>
         </a:solidFill>
+        <a:effectLst/>
       </p:bgPr>
     </p:bg>
     <p:spTree>
@@ -2166,7 +1932,9 @@
       <p:sp>
         <p:nvSpPr>
           <p:cNvPr id="2" name="Text 0"/>
-          <p:cNvSpPr/>
+          <p:cNvSpPr>
+            <a:spLocks noGrp="1"/>
+          </p:cNvSpPr>
           <p:nvPr>
             <p:ph type="title"/>
           </p:nvPr>
@@ -2188,7 +1956,7 @@
           </a:bodyPr>
           <a:lstStyle/>
           <a:p>
-            <a:pPr algn="l" indent="0" marL="0">
+            <a:pPr marL="0" indent="0" algn="l">
               <a:lnSpc>
                 <a:spcPts val="3450"/>
               </a:lnSpc>
@@ -2233,14 +2001,14 @@
       </p:sp>
       <p:pic>
         <p:nvPicPr>
-          <p:cNvPr id="4" name="Image 0" descr="Recurrence model comparison and ROC curves">    </p:cNvPr>
+          <p:cNvPr id="4" name="Image 0" descr="Recurrence model comparison and ROC curves"/>
           <p:cNvPicPr>
             <a:picLocks noChangeAspect="1"/>
           </p:cNvPicPr>
           <p:nvPr/>
         </p:nvPicPr>
         <p:blipFill>
-          <a:blip r:embed="rId1"/>
+          <a:blip r:embed="rId3"/>
           <a:stretch>
             <a:fillRect/>
           </a:stretch>
@@ -2278,7 +2046,7 @@
           </a:bodyPr>
           <a:lstStyle/>
           <a:p>
-            <a:pPr algn="l" marL="183642" indent="-183642">
+            <a:pPr marL="183642" indent="-183642" algn="l">
               <a:lnSpc>
                 <a:spcPts val="2240"/>
               </a:lnSpc>
@@ -2299,7 +2067,7 @@
             <a:endParaRPr lang="en-US" sz="1600" dirty="0"/>
           </a:p>
           <a:p>
-            <a:pPr algn="l" marL="183642" indent="-183642">
+            <a:pPr marL="183642" indent="-183642" algn="l">
               <a:lnSpc>
                 <a:spcPts val="2240"/>
               </a:lnSpc>
@@ -2320,7 +2088,7 @@
             <a:endParaRPr lang="en-US" sz="1600" dirty="0"/>
           </a:p>
           <a:p>
-            <a:pPr algn="l" marL="183642" indent="-183642">
+            <a:pPr marL="183642" indent="-183642" algn="l">
               <a:lnSpc>
                 <a:spcPts val="2240"/>
               </a:lnSpc>
@@ -2365,7 +2133,7 @@
           </a:bodyPr>
           <a:lstStyle/>
           <a:p>
-            <a:pPr algn="l" indent="0" marL="0">
+            <a:pPr marL="0" indent="0" algn="l">
               <a:lnSpc>
                 <a:spcPts val="1680"/>
               </a:lnSpc>
@@ -2402,6 +2170,7 @@
         <a:solidFill>
           <a:srgbClr val="14213D"/>
         </a:solidFill>
+        <a:effectLst/>
       </p:bgPr>
     </p:bg>
     <p:spTree>
@@ -2421,7 +2190,9 @@
       <p:sp>
         <p:nvSpPr>
           <p:cNvPr id="2" name="Text 0"/>
-          <p:cNvSpPr/>
+          <p:cNvSpPr>
+            <a:spLocks noGrp="1"/>
+          </p:cNvSpPr>
           <p:nvPr>
             <p:ph type="title"/>
           </p:nvPr>
@@ -2443,7 +2214,7 @@
           </a:bodyPr>
           <a:lstStyle/>
           <a:p>
-            <a:pPr algn="l" indent="0" marL="0">
+            <a:pPr marL="0" indent="0" algn="l">
               <a:lnSpc>
                 <a:spcPts val="3450"/>
               </a:lnSpc>
@@ -2480,16 +2251,34 @@
         </p:nvGraphicFramePr>
         <p:xfrm>
           <a:off x="822960" y="1515110"/>
-          <a:ext cx="10556240" cy="2301240"/>
+          <a:ext cx="10556241" cy="2301240"/>
         </p:xfrm>
         <a:graphic>
           <a:graphicData uri="http://schemas.openxmlformats.org/drawingml/2006/table">
             <a:tbl>
               <a:tblPr/>
               <a:tblGrid>
-                <a:gridCol w="3518747"/>
-                <a:gridCol w="3518747"/>
-                <a:gridCol w="3518747"/>
+                <a:gridCol w="3518747">
+                  <a:extLst>
+                    <a:ext uri="{9D8B030D-6E8A-4147-A177-3AD203B41FA5}">
+                      <a16:colId xmlns:a16="http://schemas.microsoft.com/office/drawing/2014/main" val="20000"/>
+                    </a:ext>
+                  </a:extLst>
+                </a:gridCol>
+                <a:gridCol w="3518747">
+                  <a:extLst>
+                    <a:ext uri="{9D8B030D-6E8A-4147-A177-3AD203B41FA5}">
+                      <a16:colId xmlns:a16="http://schemas.microsoft.com/office/drawing/2014/main" val="20001"/>
+                    </a:ext>
+                  </a:extLst>
+                </a:gridCol>
+                <a:gridCol w="3518747">
+                  <a:extLst>
+                    <a:ext uri="{9D8B030D-6E8A-4147-A177-3AD203B41FA5}">
+                      <a16:colId xmlns:a16="http://schemas.microsoft.com/office/drawing/2014/main" val="20002"/>
+                    </a:ext>
+                  </a:extLst>
+                </a:gridCol>
               </a:tblGrid>
               <a:tr h="383540">
                 <a:tc>
@@ -2497,7 +2286,7 @@
                     <a:bodyPr/>
                     <a:lstStyle/>
                     <a:p>
-                      <a:pPr indent="0" marL="0">
+                      <a:pPr marL="0" indent="0">
                         <a:lnSpc>
                           <a:spcPts val="1960"/>
                         </a:lnSpc>
@@ -2521,7 +2310,7 @@
                       </a:endParaRPr>
                     </a:p>
                   </a:txBody>
-                  <a:tcPr marL="62230" marR="62230" marT="62230" marB="62230" anchor="t">
+                  <a:tcPr marL="62230" marR="62230" marT="62230" marB="62230">
                     <a:lnL w="12700" cap="flat" cmpd="sng" algn="ctr">
                       <a:solidFill>
                         <a:srgbClr val="475165"/>
@@ -2568,7 +2357,7 @@
                     <a:bodyPr/>
                     <a:lstStyle/>
                     <a:p>
-                      <a:pPr indent="0" marL="0">
+                      <a:pPr marL="0" indent="0">
                         <a:lnSpc>
                           <a:spcPts val="1960"/>
                         </a:lnSpc>
@@ -2592,7 +2381,7 @@
                       </a:endParaRPr>
                     </a:p>
                   </a:txBody>
-                  <a:tcPr marL="62230" marR="62230" marT="62230" marB="62230" anchor="t">
+                  <a:tcPr marL="62230" marR="62230" marT="62230" marB="62230">
                     <a:lnL w="12700" cap="flat" cmpd="sng" algn="ctr">
                       <a:solidFill>
                         <a:srgbClr val="555E71"/>
@@ -2639,7 +2428,7 @@
                     <a:bodyPr/>
                     <a:lstStyle/>
                     <a:p>
-                      <a:pPr indent="0" marL="0">
+                      <a:pPr marL="0" indent="0">
                         <a:lnSpc>
                           <a:spcPts val="1960"/>
                         </a:lnSpc>
@@ -2663,7 +2452,7 @@
                       </a:endParaRPr>
                     </a:p>
                   </a:txBody>
-                  <a:tcPr marL="62230" marR="62230" marT="62230" marB="62230" anchor="t">
+                  <a:tcPr marL="62230" marR="62230" marT="62230" marB="62230">
                     <a:lnL w="12700" cap="flat" cmpd="sng" algn="ctr">
                       <a:solidFill>
                         <a:srgbClr val="555E71"/>
@@ -2705,6 +2494,11 @@
                     </a:solidFill>
                   </a:tcPr>
                 </a:tc>
+                <a:extLst>
+                  <a:ext uri="{0D108BD9-81ED-4DB2-BD59-A6C34878D82A}">
+                    <a16:rowId xmlns:a16="http://schemas.microsoft.com/office/drawing/2014/main" val="10000"/>
+                  </a:ext>
+                </a:extLst>
               </a:tr>
               <a:tr h="383540">
                 <a:tc>
@@ -2712,7 +2506,7 @@
                     <a:bodyPr/>
                     <a:lstStyle/>
                     <a:p>
-                      <a:pPr indent="0" marL="0">
+                      <a:pPr marL="0" indent="0">
                         <a:lnSpc>
                           <a:spcPts val="1960"/>
                         </a:lnSpc>
@@ -2736,7 +2530,7 @@
                       </a:endParaRPr>
                     </a:p>
                   </a:txBody>
-                  <a:tcPr marL="62230" marR="62230" marT="62230" marB="62230" anchor="t">
+                  <a:tcPr marL="62230" marR="62230" marT="62230" marB="62230">
                     <a:lnL w="12700" cap="flat" cmpd="sng" algn="ctr">
                       <a:solidFill>
                         <a:srgbClr val="475165"/>
@@ -2780,7 +2574,7 @@
                     <a:bodyPr/>
                     <a:lstStyle/>
                     <a:p>
-                      <a:pPr indent="0" marL="0">
+                      <a:pPr marL="0" indent="0">
                         <a:lnSpc>
                           <a:spcPts val="1960"/>
                         </a:lnSpc>
@@ -2804,7 +2598,7 @@
                       </a:endParaRPr>
                     </a:p>
                   </a:txBody>
-                  <a:tcPr marL="62230" marR="62230" marT="62230" marB="62230" anchor="t">
+                  <a:tcPr marL="62230" marR="62230" marT="62230" marB="62230">
                     <a:lnL w="12700" cap="flat" cmpd="sng" algn="ctr">
                       <a:solidFill>
                         <a:srgbClr val="475165"/>
@@ -2848,7 +2642,7 @@
                     <a:bodyPr/>
                     <a:lstStyle/>
                     <a:p>
-                      <a:pPr indent="0" marL="0">
+                      <a:pPr marL="0" indent="0">
                         <a:lnSpc>
                           <a:spcPts val="1960"/>
                         </a:lnSpc>
@@ -2872,7 +2666,7 @@
                       </a:endParaRPr>
                     </a:p>
                   </a:txBody>
-                  <a:tcPr marL="62230" marR="62230" marT="62230" marB="62230" anchor="t">
+                  <a:tcPr marL="62230" marR="62230" marT="62230" marB="62230">
                     <a:lnL w="12700" cap="flat" cmpd="sng" algn="ctr">
                       <a:solidFill>
                         <a:srgbClr val="475165"/>
@@ -2911,6 +2705,11 @@
                     </a:lnB>
                   </a:tcPr>
                 </a:tc>
+                <a:extLst>
+                  <a:ext uri="{0D108BD9-81ED-4DB2-BD59-A6C34878D82A}">
+                    <a16:rowId xmlns:a16="http://schemas.microsoft.com/office/drawing/2014/main" val="10001"/>
+                  </a:ext>
+                </a:extLst>
               </a:tr>
               <a:tr h="383540">
                 <a:tc>
@@ -2918,7 +2717,7 @@
                     <a:bodyPr/>
                     <a:lstStyle/>
                     <a:p>
-                      <a:pPr indent="0" marL="0">
+                      <a:pPr marL="0" indent="0">
                         <a:lnSpc>
                           <a:spcPts val="1960"/>
                         </a:lnSpc>
@@ -2942,7 +2741,7 @@
                       </a:endParaRPr>
                     </a:p>
                   </a:txBody>
-                  <a:tcPr marL="62230" marR="62230" marT="62230" marB="62230" anchor="t">
+                  <a:tcPr marL="62230" marR="62230" marT="62230" marB="62230">
                     <a:lnL w="12700" cap="flat" cmpd="sng" algn="ctr">
                       <a:solidFill>
                         <a:srgbClr val="475165"/>
@@ -2986,7 +2785,7 @@
                     <a:bodyPr/>
                     <a:lstStyle/>
                     <a:p>
-                      <a:pPr indent="0" marL="0">
+                      <a:pPr marL="0" indent="0">
                         <a:lnSpc>
                           <a:spcPts val="1960"/>
                         </a:lnSpc>
@@ -3010,7 +2809,7 @@
                       </a:endParaRPr>
                     </a:p>
                   </a:txBody>
-                  <a:tcPr marL="62230" marR="62230" marT="62230" marB="62230" anchor="t">
+                  <a:tcPr marL="62230" marR="62230" marT="62230" marB="62230">
                     <a:lnL w="12700" cap="flat" cmpd="sng" algn="ctr">
                       <a:solidFill>
                         <a:srgbClr val="475165"/>
@@ -3054,7 +2853,7 @@
                     <a:bodyPr/>
                     <a:lstStyle/>
                     <a:p>
-                      <a:pPr indent="0" marL="0">
+                      <a:pPr marL="0" indent="0">
                         <a:lnSpc>
                           <a:spcPts val="1960"/>
                         </a:lnSpc>
@@ -3078,7 +2877,7 @@
                       </a:endParaRPr>
                     </a:p>
                   </a:txBody>
-                  <a:tcPr marL="62230" marR="62230" marT="62230" marB="62230" anchor="t">
+                  <a:tcPr marL="62230" marR="62230" marT="62230" marB="62230">
                     <a:lnL w="12700" cap="flat" cmpd="sng" algn="ctr">
                       <a:solidFill>
                         <a:srgbClr val="475165"/>
@@ -3117,6 +2916,11 @@
                     </a:lnB>
                   </a:tcPr>
                 </a:tc>
+                <a:extLst>
+                  <a:ext uri="{0D108BD9-81ED-4DB2-BD59-A6C34878D82A}">
+                    <a16:rowId xmlns:a16="http://schemas.microsoft.com/office/drawing/2014/main" val="10002"/>
+                  </a:ext>
+                </a:extLst>
               </a:tr>
               <a:tr h="383540">
                 <a:tc>
@@ -3124,7 +2928,7 @@
                     <a:bodyPr/>
                     <a:lstStyle/>
                     <a:p>
-                      <a:pPr indent="0" marL="0">
+                      <a:pPr marL="0" indent="0">
                         <a:lnSpc>
                           <a:spcPts val="1960"/>
                         </a:lnSpc>
@@ -3148,7 +2952,7 @@
                       </a:endParaRPr>
                     </a:p>
                   </a:txBody>
-                  <a:tcPr marL="62230" marR="62230" marT="62230" marB="62230" anchor="t">
+                  <a:tcPr marL="62230" marR="62230" marT="62230" marB="62230">
                     <a:lnL w="12700" cap="flat" cmpd="sng" algn="ctr">
                       <a:solidFill>
                         <a:srgbClr val="475165"/>
@@ -3192,7 +2996,7 @@
                     <a:bodyPr/>
                     <a:lstStyle/>
                     <a:p>
-                      <a:pPr indent="0" marL="0">
+                      <a:pPr marL="0" indent="0">
                         <a:lnSpc>
                           <a:spcPts val="1960"/>
                         </a:lnSpc>
@@ -3216,7 +3020,7 @@
                       </a:endParaRPr>
                     </a:p>
                   </a:txBody>
-                  <a:tcPr marL="62230" marR="62230" marT="62230" marB="62230" anchor="t">
+                  <a:tcPr marL="62230" marR="62230" marT="62230" marB="62230">
                     <a:lnL w="12700" cap="flat" cmpd="sng" algn="ctr">
                       <a:solidFill>
                         <a:srgbClr val="475165"/>
@@ -3260,7 +3064,7 @@
                     <a:bodyPr/>
                     <a:lstStyle/>
                     <a:p>
-                      <a:pPr indent="0" marL="0">
+                      <a:pPr marL="0" indent="0">
                         <a:lnSpc>
                           <a:spcPts val="1960"/>
                         </a:lnSpc>
@@ -3284,7 +3088,7 @@
                       </a:endParaRPr>
                     </a:p>
                   </a:txBody>
-                  <a:tcPr marL="62230" marR="62230" marT="62230" marB="62230" anchor="t">
+                  <a:tcPr marL="62230" marR="62230" marT="62230" marB="62230">
                     <a:lnL w="12700" cap="flat" cmpd="sng" algn="ctr">
                       <a:solidFill>
                         <a:srgbClr val="475165"/>
@@ -3323,6 +3127,11 @@
                     </a:lnB>
                   </a:tcPr>
                 </a:tc>
+                <a:extLst>
+                  <a:ext uri="{0D108BD9-81ED-4DB2-BD59-A6C34878D82A}">
+                    <a16:rowId xmlns:a16="http://schemas.microsoft.com/office/drawing/2014/main" val="10003"/>
+                  </a:ext>
+                </a:extLst>
               </a:tr>
               <a:tr h="383540">
                 <a:tc>
@@ -3330,7 +3139,7 @@
                     <a:bodyPr/>
                     <a:lstStyle/>
                     <a:p>
-                      <a:pPr indent="0" marL="0">
+                      <a:pPr marL="0" indent="0">
                         <a:lnSpc>
                           <a:spcPts val="1960"/>
                         </a:lnSpc>
@@ -3354,7 +3163,7 @@
                       </a:endParaRPr>
                     </a:p>
                   </a:txBody>
-                  <a:tcPr marL="62230" marR="62230" marT="62230" marB="62230" anchor="t">
+                  <a:tcPr marL="62230" marR="62230" marT="62230" marB="62230">
                     <a:lnL w="12700" cap="flat" cmpd="sng" algn="ctr">
                       <a:solidFill>
                         <a:srgbClr val="475165"/>
@@ -3398,7 +3207,7 @@
                     <a:bodyPr/>
                     <a:lstStyle/>
                     <a:p>
-                      <a:pPr indent="0" marL="0">
+                      <a:pPr marL="0" indent="0">
                         <a:lnSpc>
                           <a:spcPts val="1960"/>
                         </a:lnSpc>
@@ -3422,7 +3231,7 @@
                       </a:endParaRPr>
                     </a:p>
                   </a:txBody>
-                  <a:tcPr marL="62230" marR="62230" marT="62230" marB="62230" anchor="t">
+                  <a:tcPr marL="62230" marR="62230" marT="62230" marB="62230">
                     <a:lnL w="12700" cap="flat" cmpd="sng" algn="ctr">
                       <a:solidFill>
                         <a:srgbClr val="475165"/>
@@ -3466,7 +3275,7 @@
                     <a:bodyPr/>
                     <a:lstStyle/>
                     <a:p>
-                      <a:pPr indent="0" marL="0">
+                      <a:pPr marL="0" indent="0">
                         <a:lnSpc>
                           <a:spcPts val="1960"/>
                         </a:lnSpc>
@@ -3490,7 +3299,7 @@
                       </a:endParaRPr>
                     </a:p>
                   </a:txBody>
-                  <a:tcPr marL="62230" marR="62230" marT="62230" marB="62230" anchor="t">
+                  <a:tcPr marL="62230" marR="62230" marT="62230" marB="62230">
                     <a:lnL w="12700" cap="flat" cmpd="sng" algn="ctr">
                       <a:solidFill>
                         <a:srgbClr val="475165"/>
@@ -3529,6 +3338,11 @@
                     </a:lnB>
                   </a:tcPr>
                 </a:tc>
+                <a:extLst>
+                  <a:ext uri="{0D108BD9-81ED-4DB2-BD59-A6C34878D82A}">
+                    <a16:rowId xmlns:a16="http://schemas.microsoft.com/office/drawing/2014/main" val="10004"/>
+                  </a:ext>
+                </a:extLst>
               </a:tr>
               <a:tr h="383540">
                 <a:tc>
@@ -3536,7 +3350,7 @@
                     <a:bodyPr/>
                     <a:lstStyle/>
                     <a:p>
-                      <a:pPr indent="0" marL="0">
+                      <a:pPr marL="0" indent="0">
                         <a:lnSpc>
                           <a:spcPts val="1960"/>
                         </a:lnSpc>
@@ -3560,7 +3374,7 @@
                       </a:endParaRPr>
                     </a:p>
                   </a:txBody>
-                  <a:tcPr marL="62230" marR="62230" marT="62230" marB="62230" anchor="t">
+                  <a:tcPr marL="62230" marR="62230" marT="62230" marB="62230">
                     <a:lnL w="12700" cap="flat" cmpd="sng" algn="ctr">
                       <a:solidFill>
                         <a:srgbClr val="475165"/>
@@ -3604,7 +3418,7 @@
                     <a:bodyPr/>
                     <a:lstStyle/>
                     <a:p>
-                      <a:pPr indent="0" marL="0">
+                      <a:pPr marL="0" indent="0">
                         <a:lnSpc>
                           <a:spcPts val="1960"/>
                         </a:lnSpc>
@@ -3628,7 +3442,7 @@
                       </a:endParaRPr>
                     </a:p>
                   </a:txBody>
-                  <a:tcPr marL="62230" marR="62230" marT="62230" marB="62230" anchor="t">
+                  <a:tcPr marL="62230" marR="62230" marT="62230" marB="62230">
                     <a:lnL w="12700" cap="flat" cmpd="sng" algn="ctr">
                       <a:solidFill>
                         <a:srgbClr val="475165"/>
@@ -3672,7 +3486,7 @@
                     <a:bodyPr/>
                     <a:lstStyle/>
                     <a:p>
-                      <a:pPr indent="0" marL="0">
+                      <a:pPr marL="0" indent="0">
                         <a:lnSpc>
                           <a:spcPts val="1960"/>
                         </a:lnSpc>
@@ -3696,7 +3510,7 @@
                       </a:endParaRPr>
                     </a:p>
                   </a:txBody>
-                  <a:tcPr marL="62230" marR="62230" marT="62230" marB="62230" anchor="t">
+                  <a:tcPr marL="62230" marR="62230" marT="62230" marB="62230">
                     <a:lnL w="12700" cap="flat" cmpd="sng" algn="ctr">
                       <a:solidFill>
                         <a:srgbClr val="475165"/>
@@ -3735,6 +3549,11 @@
                     </a:lnB>
                   </a:tcPr>
                 </a:tc>
+                <a:extLst>
+                  <a:ext uri="{0D108BD9-81ED-4DB2-BD59-A6C34878D82A}">
+                    <a16:rowId xmlns:a16="http://schemas.microsoft.com/office/drawing/2014/main" val="10005"/>
+                  </a:ext>
+                </a:extLst>
               </a:tr>
             </a:tbl>
           </a:graphicData>
@@ -3763,7 +3582,7 @@
           </a:bodyPr>
           <a:lstStyle/>
           <a:p>
-            <a:pPr algn="l" indent="0" marL="0">
+            <a:pPr marL="0" indent="0" algn="l">
               <a:lnSpc>
                 <a:spcPts val="2295"/>
               </a:lnSpc>
@@ -3800,6 +3619,7 @@
         <a:solidFill>
           <a:srgbClr val="F5F3EE"/>
         </a:solidFill>
+        <a:effectLst/>
       </p:bgPr>
     </p:bg>
     <p:spTree>
@@ -3819,7 +3639,9 @@
       <p:sp>
         <p:nvSpPr>
           <p:cNvPr id="2" name="Text 0"/>
-          <p:cNvSpPr/>
+          <p:cNvSpPr>
+            <a:spLocks noGrp="1"/>
+          </p:cNvSpPr>
           <p:nvPr>
             <p:ph type="title"/>
           </p:nvPr>
@@ -3841,7 +3663,7 @@
           </a:bodyPr>
           <a:lstStyle/>
           <a:p>
-            <a:pPr algn="l" indent="0" marL="0">
+            <a:pPr marL="0" indent="0" algn="l">
               <a:lnSpc>
                 <a:spcPts val="3450"/>
               </a:lnSpc>
@@ -3885,7 +3707,7 @@
           </a:bodyPr>
           <a:lstStyle/>
           <a:p>
-            <a:pPr algn="l" indent="0" marL="0">
+            <a:pPr marL="0" indent="0" algn="l">
               <a:lnSpc>
                 <a:spcPts val="6000"/>
               </a:lnSpc>
@@ -3929,7 +3751,7 @@
           </a:bodyPr>
           <a:lstStyle/>
           <a:p>
-            <a:pPr algn="l" indent="0" marL="0">
+            <a:pPr marL="0" indent="0" algn="l">
               <a:lnSpc>
                 <a:spcPts val="1960"/>
               </a:lnSpc>
@@ -3973,7 +3795,7 @@
           </a:bodyPr>
           <a:lstStyle/>
           <a:p>
-            <a:pPr algn="l" indent="0" marL="0">
+            <a:pPr marL="0" indent="0" algn="l">
               <a:lnSpc>
                 <a:spcPts val="6000"/>
               </a:lnSpc>
@@ -4017,7 +3839,7 @@
           </a:bodyPr>
           <a:lstStyle/>
           <a:p>
-            <a:pPr algn="l" indent="0" marL="0">
+            <a:pPr marL="0" indent="0" algn="l">
               <a:lnSpc>
                 <a:spcPts val="1960"/>
               </a:lnSpc>
@@ -4061,7 +3883,7 @@
           </a:bodyPr>
           <a:lstStyle/>
           <a:p>
-            <a:pPr algn="l" marL="176530" indent="-176530">
+            <a:pPr marL="176530" indent="-176530" algn="l">
               <a:lnSpc>
                 <a:spcPts val="2100"/>
               </a:lnSpc>
@@ -4082,7 +3904,7 @@
             <a:endParaRPr lang="en-US" sz="1500" dirty="0"/>
           </a:p>
           <a:p>
-            <a:pPr algn="l" marL="176530" indent="-176530">
+            <a:pPr marL="176530" indent="-176530" algn="l">
               <a:lnSpc>
                 <a:spcPts val="2100"/>
               </a:lnSpc>
@@ -4103,7 +3925,7 @@
             <a:endParaRPr lang="en-US" sz="1500" dirty="0"/>
           </a:p>
           <a:p>
-            <a:pPr algn="l" marL="176530" indent="-176530">
+            <a:pPr marL="176530" indent="-176530" algn="l">
               <a:lnSpc>
                 <a:spcPts val="2100"/>
               </a:lnSpc>
@@ -4124,7 +3946,7 @@
             <a:endParaRPr lang="en-US" sz="1500" dirty="0"/>
           </a:p>
           <a:p>
-            <a:pPr algn="l" marL="176530" indent="-176530">
+            <a:pPr marL="176530" indent="-176530" algn="l">
               <a:lnSpc>
                 <a:spcPts val="2100"/>
               </a:lnSpc>
@@ -4170,15 +3992,15 @@
       </p:sp>
       <p:pic>
         <p:nvPicPr>
-          <p:cNvPr id="9" name="Image 0" descr="Normalized confusion matrix across 13 complaint categories">    </p:cNvPr>
+          <p:cNvPr id="9" name="Image 0" descr="Normalized confusion matrix across 13 complaint categories"/>
           <p:cNvPicPr>
             <a:picLocks noChangeAspect="1"/>
           </p:cNvPicPr>
           <p:nvPr/>
         </p:nvPicPr>
         <p:blipFill>
-          <a:blip r:embed="rId1"/>
-          <a:srcRect l="-318" r="-318" t="0" b="0"/>
+          <a:blip r:embed="rId3"/>
+          <a:srcRect l="-318" r="-318"/>
           <a:stretch/>
         </p:blipFill>
         <p:spPr>
@@ -4216,7 +4038,7 @@
           </a:bodyPr>
           <a:lstStyle/>
           <a:p>
-            <a:pPr algn="l" indent="0" marL="0">
+            <a:pPr marL="0" indent="0" algn="l">
               <a:lnSpc>
                 <a:spcPts val="1680"/>
               </a:lnSpc>
@@ -4253,6 +4075,7 @@
         <a:solidFill>
           <a:srgbClr val="F5F3EE"/>
         </a:solidFill>
+        <a:effectLst/>
       </p:bgPr>
     </p:bg>
     <p:spTree>
@@ -4272,7 +4095,9 @@
       <p:sp>
         <p:nvSpPr>
           <p:cNvPr id="2" name="Text 0"/>
-          <p:cNvSpPr/>
+          <p:cNvSpPr>
+            <a:spLocks noGrp="1"/>
+          </p:cNvSpPr>
           <p:nvPr>
             <p:ph type="title"/>
           </p:nvPr>
@@ -4294,7 +4119,7 @@
           </a:bodyPr>
           <a:lstStyle/>
           <a:p>
-            <a:pPr algn="l" indent="0" marL="0">
+            <a:pPr marL="0" indent="0" algn="l">
               <a:lnSpc>
                 <a:spcPts val="3450"/>
               </a:lnSpc>
@@ -4339,14 +4164,14 @@
       </p:sp>
       <p:pic>
         <p:nvPicPr>
-          <p:cNvPr id="4" name="Image 0" descr="Model accuracy comparison before and after feature engineering">    </p:cNvPr>
+          <p:cNvPr id="4" name="Image 0" descr="Model accuracy comparison before and after feature engineering"/>
           <p:cNvPicPr>
             <a:picLocks noChangeAspect="1"/>
           </p:cNvPicPr>
           <p:nvPr/>
         </p:nvPicPr>
         <p:blipFill>
-          <a:blip r:embed="rId1"/>
+          <a:blip r:embed="rId3"/>
           <a:stretch>
             <a:fillRect/>
           </a:stretch>
@@ -4384,7 +4209,7 @@
           </a:bodyPr>
           <a:lstStyle/>
           <a:p>
-            <a:pPr algn="l" marL="183642" indent="-183642">
+            <a:pPr marL="183642" indent="-183642" algn="l">
               <a:lnSpc>
                 <a:spcPts val="2240"/>
               </a:lnSpc>
@@ -4405,7 +4230,7 @@
             <a:endParaRPr lang="en-US" sz="1600" dirty="0"/>
           </a:p>
           <a:p>
-            <a:pPr algn="l" marL="183642" indent="-183642">
+            <a:pPr marL="183642" indent="-183642" algn="l">
               <a:lnSpc>
                 <a:spcPts val="2240"/>
               </a:lnSpc>
@@ -4426,7 +4251,7 @@
             <a:endParaRPr lang="en-US" sz="1600" dirty="0"/>
           </a:p>
           <a:p>
-            <a:pPr algn="l" marL="183642" indent="-183642">
+            <a:pPr marL="183642" indent="-183642" algn="l">
               <a:lnSpc>
                 <a:spcPts val="2240"/>
               </a:lnSpc>
@@ -4447,7 +4272,7 @@
             <a:endParaRPr lang="en-US" sz="1600" dirty="0"/>
           </a:p>
           <a:p>
-            <a:pPr algn="l" marL="183642" indent="-183642">
+            <a:pPr marL="183642" indent="-183642" algn="l">
               <a:lnSpc>
                 <a:spcPts val="2240"/>
               </a:lnSpc>
@@ -4492,7 +4317,7 @@
           </a:bodyPr>
           <a:lstStyle/>
           <a:p>
-            <a:pPr algn="l" indent="0" marL="0">
+            <a:pPr marL="0" indent="0" algn="l">
               <a:lnSpc>
                 <a:spcPts val="1680"/>
               </a:lnSpc>
@@ -4529,6 +4354,7 @@
         <a:solidFill>
           <a:srgbClr val="14213D"/>
         </a:solidFill>
+        <a:effectLst/>
       </p:bgPr>
     </p:bg>
     <p:spTree>
@@ -4548,7 +4374,9 @@
       <p:sp>
         <p:nvSpPr>
           <p:cNvPr id="2" name="Text 0"/>
-          <p:cNvSpPr/>
+          <p:cNvSpPr>
+            <a:spLocks noGrp="1"/>
+          </p:cNvSpPr>
           <p:nvPr>
             <p:ph type="title"/>
           </p:nvPr>
@@ -4570,7 +4398,7 @@
           </a:bodyPr>
           <a:lstStyle/>
           <a:p>
-            <a:pPr algn="l" indent="0" marL="0">
+            <a:pPr marL="0" indent="0" algn="l">
               <a:lnSpc>
                 <a:spcPts val="3450"/>
               </a:lnSpc>
@@ -4638,19 +4466,19 @@
                 <a:lnTo>
                   <a:pt x="0" y="101600"/>
                 </a:lnTo>
-                <a:arcTo hR="101600" wR="101600" stAng="10800000" swAng="5400000"/>
+                <a:arcTo wR="101600" hR="101600" stAng="10800000" swAng="5400000"/>
                 <a:lnTo>
                   <a:pt x="3302000" y="0"/>
                 </a:lnTo>
-                <a:arcTo hR="101600" wR="101600" stAng="16200000" swAng="5400000"/>
+                <a:arcTo wR="101600" hR="101600" stAng="16200000" swAng="5400000"/>
                 <a:lnTo>
                   <a:pt x="3403600" y="101600"/>
                 </a:lnTo>
-                <a:arcTo hR="50800" wR="101600" stAng="0" swAng="-5400000"/>
+                <a:arcTo wR="101600" hR="50800" stAng="0" swAng="-5400000"/>
                 <a:lnTo>
                   <a:pt x="101600" y="50800"/>
                 </a:lnTo>
-                <a:arcTo hR="50800" wR="101600" stAng="16200000" swAng="-5400000"/>
+                <a:arcTo wR="101600" hR="50800" stAng="16200000" swAng="-5400000"/>
                 <a:close/>
               </a:path>
             </a:pathLst>
@@ -4684,7 +4512,7 @@
           </a:bodyPr>
           <a:lstStyle/>
           <a:p>
-            <a:pPr algn="l" indent="0" marL="0">
+            <a:pPr marL="0" indent="0" algn="l">
               <a:lnSpc>
                 <a:spcPts val="1920"/>
               </a:lnSpc>
@@ -4728,7 +4556,7 @@
           </a:bodyPr>
           <a:lstStyle/>
           <a:p>
-            <a:pPr algn="l" indent="0" marL="0">
+            <a:pPr marL="0" indent="0" algn="l">
               <a:lnSpc>
                 <a:spcPts val="1755"/>
               </a:lnSpc>
@@ -4796,19 +4624,19 @@
                 <a:lnTo>
                   <a:pt x="0" y="101600"/>
                 </a:lnTo>
-                <a:arcTo hR="101600" wR="101600" stAng="10800000" swAng="5400000"/>
+                <a:arcTo wR="101600" hR="101600" stAng="10800000" swAng="5400000"/>
                 <a:lnTo>
                   <a:pt x="3302000" y="0"/>
                 </a:lnTo>
-                <a:arcTo hR="101600" wR="101600" stAng="16200000" swAng="5400000"/>
+                <a:arcTo wR="101600" hR="101600" stAng="16200000" swAng="5400000"/>
                 <a:lnTo>
                   <a:pt x="3403600" y="101600"/>
                 </a:lnTo>
-                <a:arcTo hR="50800" wR="101600" stAng="0" swAng="-5400000"/>
+                <a:arcTo wR="101600" hR="50800" stAng="0" swAng="-5400000"/>
                 <a:lnTo>
                   <a:pt x="101600" y="50800"/>
                 </a:lnTo>
-                <a:arcTo hR="50800" wR="101600" stAng="16200000" swAng="-5400000"/>
+                <a:arcTo wR="101600" hR="50800" stAng="16200000" swAng="-5400000"/>
                 <a:close/>
               </a:path>
             </a:pathLst>
@@ -4842,7 +4670,7 @@
           </a:bodyPr>
           <a:lstStyle/>
           <a:p>
-            <a:pPr algn="l" indent="0" marL="0">
+            <a:pPr marL="0" indent="0" algn="l">
               <a:lnSpc>
                 <a:spcPts val="1920"/>
               </a:lnSpc>
@@ -4886,7 +4714,7 @@
           </a:bodyPr>
           <a:lstStyle/>
           <a:p>
-            <a:pPr algn="l" indent="0" marL="0">
+            <a:pPr marL="0" indent="0" algn="l">
               <a:lnSpc>
                 <a:spcPts val="1755"/>
               </a:lnSpc>
@@ -4954,19 +4782,19 @@
                 <a:lnTo>
                   <a:pt x="0" y="101600"/>
                 </a:lnTo>
-                <a:arcTo hR="101600" wR="101600" stAng="10800000" swAng="5400000"/>
+                <a:arcTo wR="101600" hR="101600" stAng="10800000" swAng="5400000"/>
                 <a:lnTo>
                   <a:pt x="3302000" y="0"/>
                 </a:lnTo>
-                <a:arcTo hR="101600" wR="101600" stAng="16200000" swAng="5400000"/>
+                <a:arcTo wR="101600" hR="101600" stAng="16200000" swAng="5400000"/>
                 <a:lnTo>
                   <a:pt x="3403600" y="101600"/>
                 </a:lnTo>
-                <a:arcTo hR="50800" wR="101600" stAng="0" swAng="-5400000"/>
+                <a:arcTo wR="101600" hR="50800" stAng="0" swAng="-5400000"/>
                 <a:lnTo>
                   <a:pt x="101600" y="50800"/>
                 </a:lnTo>
-                <a:arcTo hR="50800" wR="101600" stAng="16200000" swAng="-5400000"/>
+                <a:arcTo wR="101600" hR="50800" stAng="16200000" swAng="-5400000"/>
                 <a:close/>
               </a:path>
             </a:pathLst>
@@ -5000,7 +4828,7 @@
           </a:bodyPr>
           <a:lstStyle/>
           <a:p>
-            <a:pPr algn="l" indent="0" marL="0">
+            <a:pPr marL="0" indent="0" algn="l">
               <a:lnSpc>
                 <a:spcPts val="1920"/>
               </a:lnSpc>
@@ -5044,7 +4872,7 @@
           </a:bodyPr>
           <a:lstStyle/>
           <a:p>
-            <a:pPr algn="l" indent="0" marL="0">
+            <a:pPr marL="0" indent="0" algn="l">
               <a:lnSpc>
                 <a:spcPts val="1755"/>
               </a:lnSpc>
@@ -5112,19 +4940,19 @@
                 <a:lnTo>
                   <a:pt x="0" y="101600"/>
                 </a:lnTo>
-                <a:arcTo hR="101600" wR="101600" stAng="10800000" swAng="5400000"/>
+                <a:arcTo wR="101600" hR="101600" stAng="10800000" swAng="5400000"/>
                 <a:lnTo>
                   <a:pt x="3302000" y="0"/>
                 </a:lnTo>
-                <a:arcTo hR="101600" wR="101600" stAng="16200000" swAng="5400000"/>
+                <a:arcTo wR="101600" hR="101600" stAng="16200000" swAng="5400000"/>
                 <a:lnTo>
                   <a:pt x="3403600" y="101600"/>
                 </a:lnTo>
-                <a:arcTo hR="50800" wR="101600" stAng="0" swAng="-5400000"/>
+                <a:arcTo wR="101600" hR="50800" stAng="0" swAng="-5400000"/>
                 <a:lnTo>
                   <a:pt x="101600" y="50800"/>
                 </a:lnTo>
-                <a:arcTo hR="50800" wR="101600" stAng="16200000" swAng="-5400000"/>
+                <a:arcTo wR="101600" hR="50800" stAng="16200000" swAng="-5400000"/>
                 <a:close/>
               </a:path>
             </a:pathLst>
@@ -5158,7 +4986,7 @@
           </a:bodyPr>
           <a:lstStyle/>
           <a:p>
-            <a:pPr algn="l" indent="0" marL="0">
+            <a:pPr marL="0" indent="0" algn="l">
               <a:lnSpc>
                 <a:spcPts val="1920"/>
               </a:lnSpc>
@@ -5202,7 +5030,7 @@
           </a:bodyPr>
           <a:lstStyle/>
           <a:p>
-            <a:pPr algn="l" indent="0" marL="0">
+            <a:pPr marL="0" indent="0" algn="l">
               <a:lnSpc>
                 <a:spcPts val="1755"/>
               </a:lnSpc>
@@ -5270,19 +5098,19 @@
                 <a:lnTo>
                   <a:pt x="0" y="101600"/>
                 </a:lnTo>
-                <a:arcTo hR="101600" wR="101600" stAng="10800000" swAng="5400000"/>
+                <a:arcTo wR="101600" hR="101600" stAng="10800000" swAng="5400000"/>
                 <a:lnTo>
                   <a:pt x="3302000" y="0"/>
                 </a:lnTo>
-                <a:arcTo hR="101600" wR="101600" stAng="16200000" swAng="5400000"/>
+                <a:arcTo wR="101600" hR="101600" stAng="16200000" swAng="5400000"/>
                 <a:lnTo>
                   <a:pt x="3403600" y="101600"/>
                 </a:lnTo>
-                <a:arcTo hR="50800" wR="101600" stAng="0" swAng="-5400000"/>
+                <a:arcTo wR="101600" hR="50800" stAng="0" swAng="-5400000"/>
                 <a:lnTo>
                   <a:pt x="101600" y="50800"/>
                 </a:lnTo>
-                <a:arcTo hR="50800" wR="101600" stAng="16200000" swAng="-5400000"/>
+                <a:arcTo wR="101600" hR="50800" stAng="16200000" swAng="-5400000"/>
                 <a:close/>
               </a:path>
             </a:pathLst>
@@ -5316,7 +5144,7 @@
           </a:bodyPr>
           <a:lstStyle/>
           <a:p>
-            <a:pPr algn="l" indent="0" marL="0">
+            <a:pPr marL="0" indent="0" algn="l">
               <a:lnSpc>
                 <a:spcPts val="1920"/>
               </a:lnSpc>
@@ -5360,7 +5188,7 @@
           </a:bodyPr>
           <a:lstStyle/>
           <a:p>
-            <a:pPr algn="l" indent="0" marL="0">
+            <a:pPr marL="0" indent="0" algn="l">
               <a:lnSpc>
                 <a:spcPts val="1755"/>
               </a:lnSpc>
@@ -5428,19 +5256,19 @@
                 <a:lnTo>
                   <a:pt x="0" y="101600"/>
                 </a:lnTo>
-                <a:arcTo hR="101600" wR="101600" stAng="10800000" swAng="5400000"/>
+                <a:arcTo wR="101600" hR="101600" stAng="10800000" swAng="5400000"/>
                 <a:lnTo>
                   <a:pt x="3302000" y="0"/>
                 </a:lnTo>
-                <a:arcTo hR="101600" wR="101600" stAng="16200000" swAng="5400000"/>
+                <a:arcTo wR="101600" hR="101600" stAng="16200000" swAng="5400000"/>
                 <a:lnTo>
                   <a:pt x="3403600" y="101600"/>
                 </a:lnTo>
-                <a:arcTo hR="50800" wR="101600" stAng="0" swAng="-5400000"/>
+                <a:arcTo wR="101600" hR="50800" stAng="0" swAng="-5400000"/>
                 <a:lnTo>
                   <a:pt x="101600" y="50800"/>
                 </a:lnTo>
-                <a:arcTo hR="50800" wR="101600" stAng="16200000" swAng="-5400000"/>
+                <a:arcTo wR="101600" hR="50800" stAng="16200000" swAng="-5400000"/>
                 <a:close/>
               </a:path>
             </a:pathLst>
@@ -5474,7 +5302,7 @@
           </a:bodyPr>
           <a:lstStyle/>
           <a:p>
-            <a:pPr algn="l" indent="0" marL="0">
+            <a:pPr marL="0" indent="0" algn="l">
               <a:lnSpc>
                 <a:spcPts val="1920"/>
               </a:lnSpc>
@@ -5518,7 +5346,7 @@
           </a:bodyPr>
           <a:lstStyle/>
           <a:p>
-            <a:pPr algn="l" indent="0" marL="0">
+            <a:pPr marL="0" indent="0" algn="l">
               <a:lnSpc>
                 <a:spcPts val="1755"/>
               </a:lnSpc>
@@ -5562,7 +5390,7 @@
           </a:bodyPr>
           <a:lstStyle/>
           <a:p>
-            <a:pPr algn="l" indent="0" marL="0">
+            <a:pPr marL="0" indent="0" algn="l">
               <a:lnSpc>
                 <a:spcPts val="2240"/>
               </a:lnSpc>
@@ -5599,6 +5427,7 @@
         <a:solidFill>
           <a:srgbClr val="F5F3EE"/>
         </a:solidFill>
+        <a:effectLst/>
       </p:bgPr>
     </p:bg>
     <p:spTree>
@@ -5618,7 +5447,9 @@
       <p:sp>
         <p:nvSpPr>
           <p:cNvPr id="2" name="Text 0"/>
-          <p:cNvSpPr/>
+          <p:cNvSpPr>
+            <a:spLocks noGrp="1"/>
+          </p:cNvSpPr>
           <p:nvPr>
             <p:ph type="title"/>
           </p:nvPr>
@@ -5640,7 +5471,7 @@
           </a:bodyPr>
           <a:lstStyle/>
           <a:p>
-            <a:pPr algn="l" indent="0" marL="0">
+            <a:pPr marL="0" indent="0" algn="l">
               <a:lnSpc>
                 <a:spcPts val="3450"/>
               </a:lnSpc>
@@ -5685,14 +5516,14 @@
       </p:sp>
       <p:pic>
         <p:nvPicPr>
-          <p:cNvPr id="4" name="Image 0" descr="2D PCA projection of complaint types coloured by cluster">    </p:cNvPr>
+          <p:cNvPr id="4" name="Image 0" descr="2D PCA projection of complaint types coloured by cluster"/>
           <p:cNvPicPr>
             <a:picLocks noChangeAspect="1"/>
           </p:cNvPicPr>
           <p:nvPr/>
         </p:nvPicPr>
         <p:blipFill>
-          <a:blip r:embed="rId1"/>
+          <a:blip r:embed="rId3"/>
           <a:stretch>
             <a:fillRect/>
           </a:stretch>
@@ -5730,7 +5561,7 @@
           </a:bodyPr>
           <a:lstStyle/>
           <a:p>
-            <a:pPr algn="l" indent="0" marL="0">
+            <a:pPr marL="0" indent="0" algn="l">
               <a:lnSpc>
                 <a:spcPts val="2100"/>
               </a:lnSpc>
@@ -5798,19 +5629,19 @@
                 <a:lnTo>
                   <a:pt x="0" y="101600"/>
                 </a:lnTo>
-                <a:arcTo hR="101600" wR="101600" stAng="10800000" swAng="5400000"/>
+                <a:arcTo wR="101600" hR="101600" stAng="10800000" swAng="5400000"/>
                 <a:lnTo>
                   <a:pt x="5283200" y="0"/>
                 </a:lnTo>
-                <a:arcTo hR="101600" wR="101600" stAng="16200000" swAng="5400000"/>
+                <a:arcTo wR="101600" hR="101600" stAng="16200000" swAng="5400000"/>
                 <a:lnTo>
                   <a:pt x="5384800" y="101600"/>
                 </a:lnTo>
-                <a:arcTo hR="50800" wR="101600" stAng="0" swAng="-5400000"/>
+                <a:arcTo wR="101600" hR="50800" stAng="0" swAng="-5400000"/>
                 <a:lnTo>
                   <a:pt x="101600" y="50800"/>
                 </a:lnTo>
-                <a:arcTo hR="50800" wR="101600" stAng="16200000" swAng="-5400000"/>
+                <a:arcTo wR="101600" hR="50800" stAng="16200000" swAng="-5400000"/>
                 <a:close/>
               </a:path>
             </a:pathLst>
@@ -5844,7 +5675,7 @@
           </a:bodyPr>
           <a:lstStyle/>
           <a:p>
-            <a:pPr algn="l" indent="0" marL="0">
+            <a:pPr marL="0" indent="0" algn="l">
               <a:lnSpc>
                 <a:spcPts val="1370"/>
               </a:lnSpc>
@@ -5888,7 +5719,7 @@
           </a:bodyPr>
           <a:lstStyle/>
           <a:p>
-            <a:pPr algn="l" indent="0" marL="0">
+            <a:pPr marL="0" indent="0" algn="l">
               <a:lnSpc>
                 <a:spcPts val="1429"/>
               </a:lnSpc>
@@ -5956,19 +5787,19 @@
                 <a:lnTo>
                   <a:pt x="0" y="101600"/>
                 </a:lnTo>
-                <a:arcTo hR="101600" wR="101600" stAng="10800000" swAng="5400000"/>
+                <a:arcTo wR="101600" hR="101600" stAng="10800000" swAng="5400000"/>
                 <a:lnTo>
                   <a:pt x="5283200" y="0"/>
                 </a:lnTo>
-                <a:arcTo hR="101600" wR="101600" stAng="16200000" swAng="5400000"/>
+                <a:arcTo wR="101600" hR="101600" stAng="16200000" swAng="5400000"/>
                 <a:lnTo>
                   <a:pt x="5384800" y="101600"/>
                 </a:lnTo>
-                <a:arcTo hR="50800" wR="101600" stAng="0" swAng="-5400000"/>
+                <a:arcTo wR="101600" hR="50800" stAng="0" swAng="-5400000"/>
                 <a:lnTo>
                   <a:pt x="101600" y="50800"/>
                 </a:lnTo>
-                <a:arcTo hR="50800" wR="101600" stAng="16200000" swAng="-5400000"/>
+                <a:arcTo wR="101600" hR="50800" stAng="16200000" swAng="-5400000"/>
                 <a:close/>
               </a:path>
             </a:pathLst>
@@ -6002,7 +5833,7 @@
           </a:bodyPr>
           <a:lstStyle/>
           <a:p>
-            <a:pPr algn="l" indent="0" marL="0">
+            <a:pPr marL="0" indent="0" algn="l">
               <a:lnSpc>
                 <a:spcPts val="1370"/>
               </a:lnSpc>
@@ -6046,7 +5877,7 @@
           </a:bodyPr>
           <a:lstStyle/>
           <a:p>
-            <a:pPr algn="l" indent="0" marL="0">
+            <a:pPr marL="0" indent="0" algn="l">
               <a:lnSpc>
                 <a:spcPts val="1211"/>
               </a:lnSpc>
@@ -6114,19 +5945,19 @@
                 <a:lnTo>
                   <a:pt x="0" y="101600"/>
                 </a:lnTo>
-                <a:arcTo hR="101600" wR="101600" stAng="10800000" swAng="5400000"/>
+                <a:arcTo wR="101600" hR="101600" stAng="10800000" swAng="5400000"/>
                 <a:lnTo>
                   <a:pt x="5283200" y="0"/>
                 </a:lnTo>
-                <a:arcTo hR="101600" wR="101600" stAng="16200000" swAng="5400000"/>
+                <a:arcTo wR="101600" hR="101600" stAng="16200000" swAng="5400000"/>
                 <a:lnTo>
                   <a:pt x="5384800" y="101600"/>
                 </a:lnTo>
-                <a:arcTo hR="50800" wR="101600" stAng="0" swAng="-5400000"/>
+                <a:arcTo wR="101600" hR="50800" stAng="0" swAng="-5400000"/>
                 <a:lnTo>
                   <a:pt x="101600" y="50800"/>
                 </a:lnTo>
-                <a:arcTo hR="50800" wR="101600" stAng="16200000" swAng="-5400000"/>
+                <a:arcTo wR="101600" hR="50800" stAng="16200000" swAng="-5400000"/>
                 <a:close/>
               </a:path>
             </a:pathLst>
@@ -6160,7 +5991,7 @@
           </a:bodyPr>
           <a:lstStyle/>
           <a:p>
-            <a:pPr algn="l" indent="0" marL="0">
+            <a:pPr marL="0" indent="0" algn="l">
               <a:lnSpc>
                 <a:spcPts val="1370"/>
               </a:lnSpc>
@@ -6204,7 +6035,7 @@
           </a:bodyPr>
           <a:lstStyle/>
           <a:p>
-            <a:pPr algn="l" indent="0" marL="0">
+            <a:pPr marL="0" indent="0" algn="l">
               <a:lnSpc>
                 <a:spcPts val="1695"/>
               </a:lnSpc>
@@ -6248,7 +6079,7 @@
           </a:bodyPr>
           <a:lstStyle/>
           <a:p>
-            <a:pPr algn="l" indent="0" marL="0">
+            <a:pPr marL="0" indent="0" algn="l">
               <a:lnSpc>
                 <a:spcPts val="1680"/>
               </a:lnSpc>
@@ -6285,6 +6116,7 @@
         <a:solidFill>
           <a:srgbClr val="F5F3EE"/>
         </a:solidFill>
+        <a:effectLst/>
       </p:bgPr>
     </p:bg>
     <p:spTree>
@@ -6304,7 +6136,9 @@
       <p:sp>
         <p:nvSpPr>
           <p:cNvPr id="2" name="Text 0"/>
-          <p:cNvSpPr/>
+          <p:cNvSpPr>
+            <a:spLocks noGrp="1"/>
+          </p:cNvSpPr>
           <p:nvPr>
             <p:ph type="title"/>
           </p:nvPr>
@@ -6326,7 +6160,7 @@
           </a:bodyPr>
           <a:lstStyle/>
           <a:p>
-            <a:pPr algn="l" indent="0" marL="0">
+            <a:pPr marL="0" indent="0" algn="l">
               <a:lnSpc>
                 <a:spcPts val="3450"/>
               </a:lnSpc>
@@ -6371,14 +6205,14 @@
       </p:sp>
       <p:pic>
         <p:nvPicPr>
-          <p:cNvPr id="4" name="Image 0" descr="Elbow and silhouette curves for choosing K">    </p:cNvPr>
+          <p:cNvPr id="4" name="Image 0" descr="Elbow and silhouette curves for choosing K"/>
           <p:cNvPicPr>
             <a:picLocks noChangeAspect="1"/>
           </p:cNvPicPr>
           <p:nvPr/>
         </p:nvPicPr>
         <p:blipFill>
-          <a:blip r:embed="rId1"/>
+          <a:blip r:embed="rId3"/>
           <a:stretch>
             <a:fillRect/>
           </a:stretch>
@@ -6416,7 +6250,7 @@
           </a:bodyPr>
           <a:lstStyle/>
           <a:p>
-            <a:pPr algn="l" marL="183642" indent="-183642">
+            <a:pPr marL="183642" indent="-183642" algn="l">
               <a:lnSpc>
                 <a:spcPts val="2240"/>
               </a:lnSpc>
@@ -6437,7 +6271,7 @@
             <a:endParaRPr lang="en-US" sz="1600" dirty="0"/>
           </a:p>
           <a:p>
-            <a:pPr algn="l" marL="183642" indent="-183642">
+            <a:pPr marL="183642" indent="-183642" algn="l">
               <a:lnSpc>
                 <a:spcPts val="2240"/>
               </a:lnSpc>
@@ -6458,7 +6292,7 @@
             <a:endParaRPr lang="en-US" sz="1600" dirty="0"/>
           </a:p>
           <a:p>
-            <a:pPr algn="l" marL="183642" indent="-183642">
+            <a:pPr marL="183642" indent="-183642" algn="l">
               <a:lnSpc>
                 <a:spcPts val="2240"/>
               </a:lnSpc>
@@ -6479,7 +6313,7 @@
             <a:endParaRPr lang="en-US" sz="1600" dirty="0"/>
           </a:p>
           <a:p>
-            <a:pPr algn="l" marL="183642" indent="-183642">
+            <a:pPr marL="183642" indent="-183642" algn="l">
               <a:lnSpc>
                 <a:spcPts val="2240"/>
               </a:lnSpc>
@@ -6524,7 +6358,7 @@
           </a:bodyPr>
           <a:lstStyle/>
           <a:p>
-            <a:pPr algn="l" indent="0" marL="0">
+            <a:pPr marL="0" indent="0" algn="l">
               <a:lnSpc>
                 <a:spcPts val="1680"/>
               </a:lnSpc>
@@ -6561,6 +6395,7 @@
         <a:solidFill>
           <a:srgbClr val="F5F3EE"/>
         </a:solidFill>
+        <a:effectLst/>
       </p:bgPr>
     </p:bg>
     <p:spTree>
@@ -6580,7 +6415,9 @@
       <p:sp>
         <p:nvSpPr>
           <p:cNvPr id="2" name="Text 0"/>
-          <p:cNvSpPr/>
+          <p:cNvSpPr>
+            <a:spLocks noGrp="1"/>
+          </p:cNvSpPr>
           <p:nvPr>
             <p:ph type="title"/>
           </p:nvPr>
@@ -6602,7 +6439,7 @@
           </a:bodyPr>
           <a:lstStyle/>
           <a:p>
-            <a:pPr algn="l" indent="0" marL="0">
+            <a:pPr marL="0" indent="0" algn="l">
               <a:lnSpc>
                 <a:spcPts val="3450"/>
               </a:lnSpc>
@@ -6646,7 +6483,7 @@
           </a:bodyPr>
           <a:lstStyle/>
           <a:p>
-            <a:pPr algn="l" indent="0" marL="0">
+            <a:pPr marL="0" indent="0" algn="l">
               <a:lnSpc>
                 <a:spcPts val="2100"/>
               </a:lnSpc>
@@ -6714,19 +6551,19 @@
                 <a:lnTo>
                   <a:pt x="0" y="101600"/>
                 </a:lnTo>
-                <a:arcTo hR="101600" wR="101600" stAng="10800000" swAng="5400000"/>
+                <a:arcTo wR="101600" hR="101600" stAng="10800000" swAng="5400000"/>
                 <a:lnTo>
                   <a:pt x="5283200" y="0"/>
                 </a:lnTo>
-                <a:arcTo hR="101600" wR="101600" stAng="16200000" swAng="5400000"/>
+                <a:arcTo wR="101600" hR="101600" stAng="16200000" swAng="5400000"/>
                 <a:lnTo>
                   <a:pt x="5384800" y="101600"/>
                 </a:lnTo>
-                <a:arcTo hR="50800" wR="101600" stAng="0" swAng="-5400000"/>
+                <a:arcTo wR="101600" hR="50800" stAng="0" swAng="-5400000"/>
                 <a:lnTo>
                   <a:pt x="101600" y="50800"/>
                 </a:lnTo>
-                <a:arcTo hR="50800" wR="101600" stAng="16200000" swAng="-5400000"/>
+                <a:arcTo wR="101600" hR="50800" stAng="16200000" swAng="-5400000"/>
                 <a:close/>
               </a:path>
             </a:pathLst>
@@ -6760,7 +6597,7 @@
           </a:bodyPr>
           <a:lstStyle/>
           <a:p>
-            <a:pPr algn="l" indent="0" marL="0">
+            <a:pPr marL="0" indent="0" algn="l">
               <a:lnSpc>
                 <a:spcPts val="1654"/>
               </a:lnSpc>
@@ -6804,7 +6641,7 @@
           </a:bodyPr>
           <a:lstStyle/>
           <a:p>
-            <a:pPr algn="l" indent="0" marL="0">
+            <a:pPr marL="0" indent="0" algn="l">
               <a:lnSpc>
                 <a:spcPts val="1134"/>
               </a:lnSpc>
@@ -6872,19 +6709,19 @@
                 <a:lnTo>
                   <a:pt x="0" y="101600"/>
                 </a:lnTo>
-                <a:arcTo hR="101600" wR="101600" stAng="10800000" swAng="5400000"/>
+                <a:arcTo wR="101600" hR="101600" stAng="10800000" swAng="5400000"/>
                 <a:lnTo>
                   <a:pt x="5283200" y="0"/>
                 </a:lnTo>
-                <a:arcTo hR="101600" wR="101600" stAng="16200000" swAng="5400000"/>
+                <a:arcTo wR="101600" hR="101600" stAng="16200000" swAng="5400000"/>
                 <a:lnTo>
                   <a:pt x="5384800" y="101600"/>
                 </a:lnTo>
-                <a:arcTo hR="50800" wR="101600" stAng="0" swAng="-5400000"/>
+                <a:arcTo wR="101600" hR="50800" stAng="0" swAng="-5400000"/>
                 <a:lnTo>
                   <a:pt x="101600" y="50800"/>
                 </a:lnTo>
-                <a:arcTo hR="50800" wR="101600" stAng="16200000" swAng="-5400000"/>
+                <a:arcTo wR="101600" hR="50800" stAng="16200000" swAng="-5400000"/>
                 <a:close/>
               </a:path>
             </a:pathLst>
@@ -6918,7 +6755,7 @@
           </a:bodyPr>
           <a:lstStyle/>
           <a:p>
-            <a:pPr algn="l" indent="0" marL="0">
+            <a:pPr marL="0" indent="0" algn="l">
               <a:lnSpc>
                 <a:spcPts val="1458"/>
               </a:lnSpc>
@@ -6962,7 +6799,7 @@
           </a:bodyPr>
           <a:lstStyle/>
           <a:p>
-            <a:pPr algn="l" indent="0" marL="0">
+            <a:pPr marL="0" indent="0" algn="l">
               <a:lnSpc>
                 <a:spcPts val="1642"/>
               </a:lnSpc>
@@ -7030,19 +6867,19 @@
                 <a:lnTo>
                   <a:pt x="0" y="101600"/>
                 </a:lnTo>
-                <a:arcTo hR="101600" wR="101600" stAng="10800000" swAng="5400000"/>
+                <a:arcTo wR="101600" hR="101600" stAng="10800000" swAng="5400000"/>
                 <a:lnTo>
                   <a:pt x="5283200" y="0"/>
                 </a:lnTo>
-                <a:arcTo hR="101600" wR="101600" stAng="16200000" swAng="5400000"/>
+                <a:arcTo wR="101600" hR="101600" stAng="16200000" swAng="5400000"/>
                 <a:lnTo>
                   <a:pt x="5384800" y="101600"/>
                 </a:lnTo>
-                <a:arcTo hR="50800" wR="101600" stAng="0" swAng="-5400000"/>
+                <a:arcTo wR="101600" hR="50800" stAng="0" swAng="-5400000"/>
                 <a:lnTo>
                   <a:pt x="101600" y="50800"/>
                 </a:lnTo>
-                <a:arcTo hR="50800" wR="101600" stAng="16200000" swAng="-5400000"/>
+                <a:arcTo wR="101600" hR="50800" stAng="16200000" swAng="-5400000"/>
                 <a:close/>
               </a:path>
             </a:pathLst>
@@ -7076,7 +6913,7 @@
           </a:bodyPr>
           <a:lstStyle/>
           <a:p>
-            <a:pPr algn="l" indent="0" marL="0">
+            <a:pPr marL="0" indent="0" algn="l">
               <a:lnSpc>
                 <a:spcPts val="1370"/>
               </a:lnSpc>
@@ -7120,7 +6957,7 @@
           </a:bodyPr>
           <a:lstStyle/>
           <a:p>
-            <a:pPr algn="l" indent="0" marL="0">
+            <a:pPr marL="0" indent="0" algn="l">
               <a:lnSpc>
                 <a:spcPts val="1695"/>
               </a:lnSpc>
@@ -7165,14 +7002,14 @@
       </p:sp>
       <p:pic>
         <p:nvPicPr>
-          <p:cNvPr id="17" name="Image 0" descr="Association rules scatter of support, confidence and lift">    </p:cNvPr>
+          <p:cNvPr id="17" name="Image 0" descr="Association rules scatter of support, confidence and lift"/>
           <p:cNvPicPr>
             <a:picLocks noChangeAspect="1"/>
           </p:cNvPicPr>
           <p:nvPr/>
         </p:nvPicPr>
         <p:blipFill>
-          <a:blip r:embed="rId1"/>
+          <a:blip r:embed="rId3"/>
           <a:stretch>
             <a:fillRect/>
           </a:stretch>
@@ -7210,7 +7047,7 @@
           </a:bodyPr>
           <a:lstStyle/>
           <a:p>
-            <a:pPr algn="l" indent="0" marL="0">
+            <a:pPr marL="0" indent="0" algn="l">
               <a:lnSpc>
                 <a:spcPts val="1680"/>
               </a:lnSpc>
@@ -7247,6 +7084,7 @@
         <a:solidFill>
           <a:srgbClr val="F5F3EE"/>
         </a:solidFill>
+        <a:effectLst/>
       </p:bgPr>
     </p:bg>
     <p:spTree>
@@ -7266,7 +7104,9 @@
       <p:sp>
         <p:nvSpPr>
           <p:cNvPr id="2" name="Text 0"/>
-          <p:cNvSpPr/>
+          <p:cNvSpPr>
+            <a:spLocks noGrp="1"/>
+          </p:cNvSpPr>
           <p:nvPr>
             <p:ph type="title"/>
           </p:nvPr>
@@ -7288,7 +7128,7 @@
           </a:bodyPr>
           <a:lstStyle/>
           <a:p>
-            <a:pPr algn="l" indent="0" marL="0">
+            <a:pPr marL="0" indent="0" algn="l">
               <a:lnSpc>
                 <a:spcPts val="3450"/>
               </a:lnSpc>
@@ -7317,8 +7157,8 @@
         </p:nvSpPr>
         <p:spPr>
           <a:xfrm>
-            <a:off x="812800" y="1504950"/>
-            <a:ext cx="6096000" cy="4191000"/>
+            <a:off x="463590" y="1537896"/>
+            <a:ext cx="7184572" cy="4419989"/>
           </a:xfrm>
           <a:prstGeom prst="roundRect">
             <a:avLst>
@@ -7333,22 +7173,22 @@
       </p:sp>
       <p:pic>
         <p:nvPicPr>
-          <p:cNvPr id="4" name="Image 0" descr="Card of top complaint cause association rules">    </p:cNvPr>
+          <p:cNvPr id="4" name="Image 0" descr="Card of top complaint cause association rules"/>
           <p:cNvPicPr>
             <a:picLocks noChangeAspect="1"/>
           </p:cNvPicPr>
           <p:nvPr/>
         </p:nvPicPr>
         <p:blipFill>
-          <a:blip r:embed="rId1"/>
+          <a:blip r:embed="rId3"/>
           <a:stretch>
             <a:fillRect/>
           </a:stretch>
         </p:blipFill>
         <p:spPr>
           <a:xfrm>
-            <a:off x="812800" y="2755833"/>
-            <a:ext cx="6096000" cy="1689234"/>
+            <a:off x="488000" y="2755832"/>
+            <a:ext cx="7160162" cy="1984119"/>
           </a:xfrm>
           <a:prstGeom prst="rect">
             <a:avLst/>
@@ -7363,7 +7203,7 @@
         </p:nvSpPr>
         <p:spPr>
           <a:xfrm>
-            <a:off x="7334758" y="2677796"/>
+            <a:off x="7882444" y="2420620"/>
             <a:ext cx="4160266" cy="2016760"/>
           </a:xfrm>
           <a:prstGeom prst="rect">
@@ -7378,7 +7218,7 @@
           </a:bodyPr>
           <a:lstStyle/>
           <a:p>
-            <a:pPr algn="l" marL="183642" indent="-183642">
+            <a:pPr marL="183642" indent="-183642" algn="l">
               <a:lnSpc>
                 <a:spcPts val="2240"/>
               </a:lnSpc>
@@ -7399,7 +7239,7 @@
             <a:endParaRPr lang="en-US" sz="1600" dirty="0"/>
           </a:p>
           <a:p>
-            <a:pPr algn="l" marL="183642" indent="-183642">
+            <a:pPr marL="183642" indent="-183642" algn="l">
               <a:lnSpc>
                 <a:spcPts val="2240"/>
               </a:lnSpc>
@@ -7420,7 +7260,7 @@
             <a:endParaRPr lang="en-US" sz="1600" dirty="0"/>
           </a:p>
           <a:p>
-            <a:pPr algn="l" marL="183642" indent="-183642">
+            <a:pPr marL="183642" indent="-183642" algn="l">
               <a:lnSpc>
                 <a:spcPts val="2240"/>
               </a:lnSpc>
@@ -7441,7 +7281,7 @@
             <a:endParaRPr lang="en-US" sz="1600" dirty="0"/>
           </a:p>
           <a:p>
-            <a:pPr algn="l" marL="183642" indent="-183642">
+            <a:pPr marL="183642" indent="-183642" algn="l">
               <a:lnSpc>
                 <a:spcPts val="2240"/>
               </a:lnSpc>
@@ -7486,7 +7326,7 @@
           </a:bodyPr>
           <a:lstStyle/>
           <a:p>
-            <a:pPr algn="l" indent="0" marL="0">
+            <a:pPr marL="0" indent="0" algn="l">
               <a:lnSpc>
                 <a:spcPts val="1680"/>
               </a:lnSpc>
@@ -7523,6 +7363,7 @@
         <a:solidFill>
           <a:srgbClr val="F5F3EE"/>
         </a:solidFill>
+        <a:effectLst/>
       </p:bgPr>
     </p:bg>
     <p:spTree>
@@ -7542,7 +7383,9 @@
       <p:sp>
         <p:nvSpPr>
           <p:cNvPr id="2" name="Text 0"/>
-          <p:cNvSpPr/>
+          <p:cNvSpPr>
+            <a:spLocks noGrp="1"/>
+          </p:cNvSpPr>
           <p:nvPr>
             <p:ph type="title"/>
           </p:nvPr>
@@ -7564,7 +7407,7 @@
           </a:bodyPr>
           <a:lstStyle/>
           <a:p>
-            <a:pPr algn="l" indent="0" marL="0">
+            <a:pPr marL="0" indent="0" algn="l">
               <a:lnSpc>
                 <a:spcPts val="3450"/>
               </a:lnSpc>
@@ -7608,7 +7451,7 @@
           </a:bodyPr>
           <a:lstStyle/>
           <a:p>
-            <a:pPr algn="l" indent="0" marL="0">
+            <a:pPr marL="0" indent="0" algn="l">
               <a:lnSpc>
                 <a:spcPts val="6000"/>
               </a:lnSpc>
@@ -7652,7 +7495,7 @@
           </a:bodyPr>
           <a:lstStyle/>
           <a:p>
-            <a:pPr algn="l" indent="0" marL="0">
+            <a:pPr marL="0" indent="0" algn="l">
               <a:lnSpc>
                 <a:spcPts val="1960"/>
               </a:lnSpc>
@@ -7696,7 +7539,7 @@
           </a:bodyPr>
           <a:lstStyle/>
           <a:p>
-            <a:pPr algn="l" indent="0" marL="0">
+            <a:pPr marL="0" indent="0" algn="l">
               <a:lnSpc>
                 <a:spcPts val="6000"/>
               </a:lnSpc>
@@ -7740,7 +7583,7 @@
           </a:bodyPr>
           <a:lstStyle/>
           <a:p>
-            <a:pPr algn="l" indent="0" marL="0">
+            <a:pPr marL="0" indent="0" algn="l">
               <a:lnSpc>
                 <a:spcPts val="1960"/>
               </a:lnSpc>
@@ -7784,7 +7627,7 @@
           </a:bodyPr>
           <a:lstStyle/>
           <a:p>
-            <a:pPr algn="l" marL="176530" indent="-176530">
+            <a:pPr marL="176530" indent="-176530" algn="l">
               <a:lnSpc>
                 <a:spcPts val="2100"/>
               </a:lnSpc>
@@ -7805,7 +7648,7 @@
             <a:endParaRPr lang="en-US" sz="1500" dirty="0"/>
           </a:p>
           <a:p>
-            <a:pPr algn="l" marL="176530" indent="-176530">
+            <a:pPr marL="176530" indent="-176530" algn="l">
               <a:lnSpc>
                 <a:spcPts val="2100"/>
               </a:lnSpc>
@@ -7826,7 +7669,7 @@
             <a:endParaRPr lang="en-US" sz="1500" dirty="0"/>
           </a:p>
           <a:p>
-            <a:pPr algn="l" marL="176530" indent="-176530">
+            <a:pPr marL="176530" indent="-176530" algn="l">
               <a:lnSpc>
                 <a:spcPts val="2100"/>
               </a:lnSpc>
@@ -7872,14 +7715,14 @@
       </p:sp>
       <p:pic>
         <p:nvPicPr>
-          <p:cNvPr id="9" name="Image 0" descr="Top 10 feature importances for recurrence prediction">    </p:cNvPr>
+          <p:cNvPr id="9" name="Image 0" descr="Top 10 feature importances for recurrence prediction"/>
           <p:cNvPicPr>
             <a:picLocks noChangeAspect="1"/>
           </p:cNvPicPr>
           <p:nvPr/>
         </p:nvPicPr>
         <p:blipFill>
-          <a:blip r:embed="rId1"/>
+          <a:blip r:embed="rId3"/>
           <a:stretch>
             <a:fillRect/>
           </a:stretch>
@@ -7917,7 +7760,7 @@
           </a:bodyPr>
           <a:lstStyle/>
           <a:p>
-            <a:pPr algn="l" indent="0" marL="0">
+            <a:pPr marL="0" indent="0" algn="l">
               <a:lnSpc>
                 <a:spcPts val="1680"/>
               </a:lnSpc>
@@ -8234,4 +8077,299 @@
   <a:objectDefaults/>
   <a:extraClrSchemeLst/>
 </a:theme>
+</file>
+
+<file path=ppt/theme/theme2.xml><?xml version="1.0" encoding="utf-8"?>
+<a:theme xmlns:a="http://schemas.openxmlformats.org/drawingml/2006/main" name="Office Theme">
+  <a:themeElements>
+    <a:clrScheme name="Office">
+      <a:dk1>
+        <a:sysClr val="windowText" lastClr="000000"/>
+      </a:dk1>
+      <a:lt1>
+        <a:sysClr val="window" lastClr="FFFFFF"/>
+      </a:lt1>
+      <a:dk2>
+        <a:srgbClr val="44546A"/>
+      </a:dk2>
+      <a:lt2>
+        <a:srgbClr val="E7E6E6"/>
+      </a:lt2>
+      <a:accent1>
+        <a:srgbClr val="4472C4"/>
+      </a:accent1>
+      <a:accent2>
+        <a:srgbClr val="ED7D31"/>
+      </a:accent2>
+      <a:accent3>
+        <a:srgbClr val="A5A5A5"/>
+      </a:accent3>
+      <a:accent4>
+        <a:srgbClr val="FFC000"/>
+      </a:accent4>
+      <a:accent5>
+        <a:srgbClr val="5B9BD5"/>
+      </a:accent5>
+      <a:accent6>
+        <a:srgbClr val="70AD47"/>
+      </a:accent6>
+      <a:hlink>
+        <a:srgbClr val="0563C1"/>
+      </a:hlink>
+      <a:folHlink>
+        <a:srgbClr val="954F72"/>
+      </a:folHlink>
+    </a:clrScheme>
+    <a:fontScheme name="Office">
+      <a:majorFont>
+        <a:latin typeface="Calibri Light" panose="020F0302020204030204"/>
+        <a:ea typeface=""/>
+        <a:cs typeface=""/>
+        <a:font script="Jpan" typeface="游ゴシック Light"/>
+        <a:font script="Hang" typeface="맑은 고딕"/>
+        <a:font script="Hans" typeface="等线 Light"/>
+        <a:font script="Hant" typeface="新細明體"/>
+        <a:font script="Arab" typeface="Times New Roman"/>
+        <a:font script="Hebr" typeface="Times New Roman"/>
+        <a:font script="Thai" typeface="Angsana New"/>
+        <a:font script="Ethi" typeface="Nyala"/>
+        <a:font script="Beng" typeface="Vrinda"/>
+        <a:font script="Gujr" typeface="Shruti"/>
+        <a:font script="Khmr" typeface="MoolBoran"/>
+        <a:font script="Knda" typeface="Tunga"/>
+        <a:font script="Guru" typeface="Raavi"/>
+        <a:font script="Cans" typeface="Euphemia"/>
+        <a:font script="Cher" typeface="Plantagenet Cherokee"/>
+        <a:font script="Yiii" typeface="Microsoft Yi Baiti"/>
+        <a:font script="Tibt" typeface="Microsoft Himalaya"/>
+        <a:font script="Thaa" typeface="MV Boli"/>
+        <a:font script="Deva" typeface="Mangal"/>
+        <a:font script="Telu" typeface="Gautami"/>
+        <a:font script="Taml" typeface="Latha"/>
+        <a:font script="Syrc" typeface="Estrangelo Edessa"/>
+        <a:font script="Orya" typeface="Kalinga"/>
+        <a:font script="Mlym" typeface="Kartika"/>
+        <a:font script="Laoo" typeface="DokChampa"/>
+        <a:font script="Sinh" typeface="Iskoola Pota"/>
+        <a:font script="Mong" typeface="Mongolian Baiti"/>
+        <a:font script="Viet" typeface="Times New Roman"/>
+        <a:font script="Uigh" typeface="Microsoft Uighur"/>
+        <a:font script="Geor" typeface="Sylfaen"/>
+        <a:font script="Armn" typeface="Arial"/>
+        <a:font script="Bugi" typeface="Leelawadee UI"/>
+        <a:font script="Bopo" typeface="Microsoft JhengHei"/>
+        <a:font script="Java" typeface="Javanese Text"/>
+        <a:font script="Lisu" typeface="Segoe UI"/>
+        <a:font script="Mymr" typeface="Myanmar Text"/>
+        <a:font script="Nkoo" typeface="Ebrima"/>
+        <a:font script="Olck" typeface="Nirmala UI"/>
+        <a:font script="Osma" typeface="Ebrima"/>
+        <a:font script="Phag" typeface="Phagspa"/>
+        <a:font script="Syrn" typeface="Estrangelo Edessa"/>
+        <a:font script="Syrj" typeface="Estrangelo Edessa"/>
+        <a:font script="Syre" typeface="Estrangelo Edessa"/>
+        <a:font script="Sora" typeface="Nirmala UI"/>
+        <a:font script="Tale" typeface="Microsoft Tai Le"/>
+        <a:font script="Talu" typeface="Microsoft New Tai Lue"/>
+        <a:font script="Tfng" typeface="Ebrima"/>
+      </a:majorFont>
+      <a:minorFont>
+        <a:latin typeface="Calibri" panose="020F0502020204030204"/>
+        <a:ea typeface=""/>
+        <a:cs typeface=""/>
+        <a:font script="Jpan" typeface="游ゴシック"/>
+        <a:font script="Hang" typeface="맑은 고딕"/>
+        <a:font script="Hans" typeface="等线"/>
+        <a:font script="Hant" typeface="新細明體"/>
+        <a:font script="Arab" typeface="Arial"/>
+        <a:font script="Hebr" typeface="Arial"/>
+        <a:font script="Thai" typeface="Cordia New"/>
+        <a:font script="Ethi" typeface="Nyala"/>
+        <a:font script="Beng" typeface="Vrinda"/>
+        <a:font script="Gujr" typeface="Shruti"/>
+        <a:font script="Khmr" typeface="DaunPenh"/>
+        <a:font script="Knda" typeface="Tunga"/>
+        <a:font script="Guru" typeface="Raavi"/>
+        <a:font script="Cans" typeface="Euphemia"/>
+        <a:font script="Cher" typeface="Plantagenet Cherokee"/>
+        <a:font script="Yiii" typeface="Microsoft Yi Baiti"/>
+        <a:font script="Tibt" typeface="Microsoft Himalaya"/>
+        <a:font script="Thaa" typeface="MV Boli"/>
+        <a:font script="Deva" typeface="Mangal"/>
+        <a:font script="Telu" typeface="Gautami"/>
+        <a:font script="Taml" typeface="Latha"/>
+        <a:font script="Syrc" typeface="Estrangelo Edessa"/>
+        <a:font script="Orya" typeface="Kalinga"/>
+        <a:font script="Mlym" typeface="Kartika"/>
+        <a:font script="Laoo" typeface="DokChampa"/>
+        <a:font script="Sinh" typeface="Iskoola Pota"/>
+        <a:font script="Mong" typeface="Mongolian Baiti"/>
+        <a:font script="Viet" typeface="Arial"/>
+        <a:font script="Uigh" typeface="Microsoft Uighur"/>
+        <a:font script="Geor" typeface="Sylfaen"/>
+        <a:font script="Armn" typeface="Arial"/>
+        <a:font script="Bugi" typeface="Leelawadee UI"/>
+        <a:font script="Bopo" typeface="Microsoft JhengHei"/>
+        <a:font script="Java" typeface="Javanese Text"/>
+        <a:font script="Lisu" typeface="Segoe UI"/>
+        <a:font script="Mymr" typeface="Myanmar Text"/>
+        <a:font script="Nkoo" typeface="Ebrima"/>
+        <a:font script="Olck" typeface="Nirmala UI"/>
+        <a:font script="Osma" typeface="Ebrima"/>
+        <a:font script="Phag" typeface="Phagspa"/>
+        <a:font script="Syrn" typeface="Estrangelo Edessa"/>
+        <a:font script="Syrj" typeface="Estrangelo Edessa"/>
+        <a:font script="Syre" typeface="Estrangelo Edessa"/>
+        <a:font script="Sora" typeface="Nirmala UI"/>
+        <a:font script="Tale" typeface="Microsoft Tai Le"/>
+        <a:font script="Talu" typeface="Microsoft New Tai Lue"/>
+        <a:font script="Tfng" typeface="Ebrima"/>
+      </a:minorFont>
+    </a:fontScheme>
+    <a:fmtScheme name="Office">
+      <a:fillStyleLst>
+        <a:solidFill>
+          <a:schemeClr val="phClr"/>
+        </a:solidFill>
+        <a:gradFill rotWithShape="1">
+          <a:gsLst>
+            <a:gs pos="0">
+              <a:schemeClr val="phClr">
+                <a:lumMod val="110000"/>
+                <a:satMod val="105000"/>
+                <a:tint val="67000"/>
+              </a:schemeClr>
+            </a:gs>
+            <a:gs pos="50000">
+              <a:schemeClr val="phClr">
+                <a:lumMod val="105000"/>
+                <a:satMod val="103000"/>
+                <a:tint val="73000"/>
+              </a:schemeClr>
+            </a:gs>
+            <a:gs pos="100000">
+              <a:schemeClr val="phClr">
+                <a:lumMod val="105000"/>
+                <a:satMod val="109000"/>
+                <a:tint val="81000"/>
+              </a:schemeClr>
+            </a:gs>
+          </a:gsLst>
+          <a:lin ang="5400000" scaled="0"/>
+        </a:gradFill>
+        <a:gradFill rotWithShape="1">
+          <a:gsLst>
+            <a:gs pos="0">
+              <a:schemeClr val="phClr">
+                <a:satMod val="103000"/>
+                <a:lumMod val="102000"/>
+                <a:tint val="94000"/>
+              </a:schemeClr>
+            </a:gs>
+            <a:gs pos="50000">
+              <a:schemeClr val="phClr">
+                <a:satMod val="110000"/>
+                <a:lumMod val="100000"/>
+                <a:shade val="100000"/>
+              </a:schemeClr>
+            </a:gs>
+            <a:gs pos="100000">
+              <a:schemeClr val="phClr">
+                <a:lumMod val="99000"/>
+                <a:satMod val="120000"/>
+                <a:shade val="78000"/>
+              </a:schemeClr>
+            </a:gs>
+          </a:gsLst>
+          <a:lin ang="5400000" scaled="0"/>
+        </a:gradFill>
+      </a:fillStyleLst>
+      <a:lnStyleLst>
+        <a:ln w="6350" cap="flat" cmpd="sng" algn="ctr">
+          <a:solidFill>
+            <a:schemeClr val="phClr"/>
+          </a:solidFill>
+          <a:prstDash val="solid"/>
+          <a:miter lim="800000"/>
+        </a:ln>
+        <a:ln w="12700" cap="flat" cmpd="sng" algn="ctr">
+          <a:solidFill>
+            <a:schemeClr val="phClr"/>
+          </a:solidFill>
+          <a:prstDash val="solid"/>
+          <a:miter lim="800000"/>
+        </a:ln>
+        <a:ln w="19050" cap="flat" cmpd="sng" algn="ctr">
+          <a:solidFill>
+            <a:schemeClr val="phClr"/>
+          </a:solidFill>
+          <a:prstDash val="solid"/>
+          <a:miter lim="800000"/>
+        </a:ln>
+      </a:lnStyleLst>
+      <a:effectStyleLst>
+        <a:effectStyle>
+          <a:effectLst/>
+        </a:effectStyle>
+        <a:effectStyle>
+          <a:effectLst/>
+        </a:effectStyle>
+        <a:effectStyle>
+          <a:effectLst>
+            <a:outerShdw blurRad="57150" dist="19050" dir="5400000" algn="ctr" rotWithShape="0">
+              <a:srgbClr val="000000">
+                <a:alpha val="63000"/>
+              </a:srgbClr>
+            </a:outerShdw>
+          </a:effectLst>
+        </a:effectStyle>
+      </a:effectStyleLst>
+      <a:bgFillStyleLst>
+        <a:solidFill>
+          <a:schemeClr val="phClr"/>
+        </a:solidFill>
+        <a:solidFill>
+          <a:schemeClr val="phClr">
+            <a:tint val="95000"/>
+            <a:satMod val="170000"/>
+          </a:schemeClr>
+        </a:solidFill>
+        <a:gradFill rotWithShape="1">
+          <a:gsLst>
+            <a:gs pos="0">
+              <a:schemeClr val="phClr">
+                <a:tint val="93000"/>
+                <a:satMod val="150000"/>
+                <a:shade val="98000"/>
+                <a:lumMod val="102000"/>
+              </a:schemeClr>
+            </a:gs>
+            <a:gs pos="50000">
+              <a:schemeClr val="phClr">
+                <a:tint val="98000"/>
+                <a:satMod val="130000"/>
+                <a:shade val="90000"/>
+                <a:lumMod val="103000"/>
+              </a:schemeClr>
+            </a:gs>
+            <a:gs pos="100000">
+              <a:schemeClr val="phClr">
+                <a:shade val="63000"/>
+                <a:satMod val="120000"/>
+              </a:schemeClr>
+            </a:gs>
+          </a:gsLst>
+          <a:lin ang="5400000" scaled="0"/>
+        </a:gradFill>
+      </a:bgFillStyleLst>
+    </a:fmtScheme>
+  </a:themeElements>
+  <a:objectDefaults/>
+  <a:extraClrSchemeLst/>
+  <a:extLst>
+    <a:ext uri="{05A4C25C-085E-4340-85A3-A5531E510DB2}">
+      <thm15:themeFamily xmlns:thm15="http://schemas.microsoft.com/office/thememl/2012/main" name="Office Theme" id="{62F939B6-93AF-4DB8-9C6B-D6C7DFDC589F}" vid="{4A3C46E8-61CC-4603-A589-7422A47A8E4A}"/>
+    </a:ext>
+  </a:extLst>
+</a:theme>
 </file>
</xml_diff>